<commit_message>
Banca 2: queda em 0,300 com o diagnóstico 61 auditado (auditoria 33), em duas ideias e sem selo
- Sai o selo PRELIMINAR nos dois decks; o slide fica em duas ideias ("é a
  estimativa no corte, não os dados"; "as vagas do lado de cima eram
  diferentes") e no fecho "nada disso mostra que a bolsa reduz o
  preenchimento: o corte junta a bolsa com outras regras", fiel à auditoria 33, §8.
- Correção M1: "menos células com candidato de 1ª opção" só nas notas, como
  estimativa imprecisa.
- Novos códigos DQ_CONCUF_* e DQ_SOCR_C2_*; os DQ_* levam a auditoria 33 no
  registro e no 03.
- Deck curto: no modo de coluna, a cautela vai sob a figura, que fica maior.
- Testes: 124 OK; validate.py --original aprovado nos dois .pptx.

Co-Authored-By: Claude Opus 5.5 <noreply@anthropic.com>
Claude-Session: https://claude.ai/code/session_011jPV4G6BtUxSX71P3Fzkr7
</commit_message>
<xml_diff>
--- a/output/apresentacao_banca2/deck_banca2_curto.pptx
+++ b/output/apresentacao_banca2/deck_banca2_curto.pptx
@@ -9097,7 +9097,7 @@
           <a:p>
             <a:r>
               <a:rPr lang="pt-BR" dirty="0"/>
-              <a:t>PRELIMINAR: diagnóstico do protocolo 61, ainda em auditoria; descreve o que acompanha a queda, não a causa, e é pós-resultado. Q1 é N1 com controle; Q2, a taxa por vaga oferecida; Q3, a célula aberta preenchida. Sem reta nem efeitos fixos, 33,3% das células da janela são preenchidas abaixo de 0,300 e 33,5% acima. Acima do corte, a parte das células só de cadastro reserva é +15,4 p.p. maior [+2,1; +28,6], o índice de curso é −4,5 p.p. [−7,1; −2,0], e a chance de a célula ter candidato de 1ª opção muda −10,8 p.p. [−28,2; +6,7], com IC que contém zero. Igualando a composição, Q2 vai a −5,1 p.p., 32% do original; igualando a concorrência, a −4,3 p.p., 27%; igualando quem teve candidato de 1ª opção, Q1 vai a −0,49, 34%. Acaso: com os 3 cortes falsos do protocolo, o p por posto é 0,250, o menor possível; numa grade maior, fora do protocolo, 0,031. O corte junta a bolsa com outras regras federais.</a:t>
+              <a:t>Diagnóstico do protocolo 61 (doc 57l), auditado (auditoria 33, aprovado com correções de texto): descritivo e pós-resultado. Q1 é N1 com controle; Q2, a taxa por vaga oferecida; Q3, a célula aberta preenchida. Nas médias da janela, sem reta nem efeitos fixos, 33,3% das células são preenchidas abaixo de 0,300 e 33,5% acima. Do lado de cima: índice de curso −4,5 p.p. [−7,1; −2,0] (cursos que preenchem pouco em qualquer lugar); +10,6 [+3,5; +17,8] células do mesmo curso na mesma UF; no ciclo 2, +28,4 p.p. [+8,3; +48,4] de células só de reserva. Que menos células tiveram candidato de 1ª opção é estimativa imprecisa: −10,8 p.p. [−28,2; +6,7]. Igualando a composição, Q2 vai a −5,1 p.p., 32% do original; a concorrência, Q2 a −4,3 p.p., 27%; quem teve candidato de 1ª opção, Q1 a −0,49, 34%; nenhum fator reduz a queda à metade nas três medidas. Acaso: com os 3 cortes falsos do protocolo, o p por posto é 0,250, o menor possível; numa grade maior, fora do protocolo, 0,031. Esses fatores se formam depois do anúncio da faixa: descrevem o que acompanha a queda, não a causa. Cautela: Nada disso mostra que a bolsa reduz o preenchimento: o corte junta a bolsa com outras regras.</a:t>
             </a:r>
           </a:p>
         </p:txBody>
@@ -18311,7 +18311,7 @@
       </p:sp>
       <p:pic>
         <p:nvPicPr>
-          <p:cNvPr id="101" name="Figura" descr="Diagnóstico do protocolo 61 (preliminar): quanto da queda em 0,300 sobra ao igualar cada fator entre os lados do corte, para Q1, Q2 e Q3, com IC 95%"/>
+          <p:cNvPr id="101" name="Figura" descr="Diagnóstico do protocolo 61: quanto da queda em 0,300 sobra ao igualar cada fator entre os lados do corte, para Q1, Q2 e Q3, com IC 95%"/>
           <p:cNvPicPr>
             <a:picLocks noChangeAspect="1"/>
           </p:cNvPicPr>
@@ -18325,8 +18325,8 @@
         </p:blipFill>
         <p:spPr>
           <a:xfrm>
-            <a:off x="292608" y="1542593"/>
-            <a:ext cx="6839712" cy="3077870"/>
+            <a:off x="292608" y="1447749"/>
+            <a:ext cx="6748272" cy="3036722"/>
           </a:xfrm>
           <a:prstGeom prst="rect">
             <a:avLst/>
@@ -18340,34 +18340,34 @@
       </p:pic>
       <p:sp>
         <p:nvSpPr>
-          <p:cNvPr id="102" name="Selo"/>
+          <p:cNvPr id="102" name="Cautela"/>
           <p:cNvSpPr/>
           <p:nvPr/>
         </p:nvSpPr>
         <p:spPr>
           <a:xfrm>
-            <a:off x="292608" y="4785055"/>
-            <a:ext cx="6839712" cy="566928"/>
+            <a:off x="292608" y="4649064"/>
+            <a:ext cx="6748272" cy="797763"/>
           </a:xfrm>
           <a:prstGeom prst="roundRect">
             <a:avLst>
-              <a:gd name="adj" fmla="val 18000"/>
+              <a:gd name="adj" fmla="val 8000"/>
             </a:avLst>
           </a:prstGeom>
           <a:solidFill>
-            <a:srgbClr val="B3261E"/>
+            <a:srgbClr val="E7F1EA"/>
           </a:solidFill>
           <a:ln>
             <a:noFill/>
           </a:ln>
         </p:spPr>
         <p:txBody>
-          <a:bodyPr wrap="square" lIns="137160" tIns="27432" rIns="137160" bIns="27432" rtlCol="0" anchor="ctr">
+          <a:bodyPr wrap="square" lIns="182880" tIns="54864" rIns="182880" bIns="54864" rtlCol="0" anchor="ctr">
             <a:noAutofit/>
           </a:bodyPr>
           <a:lstStyle/>
           <a:p>
-            <a:pPr marL="0" indent="0" algn="ctr">
+            <a:pPr marL="0" indent="0" algn="l">
               <a:lnSpc>
                 <a:spcPct val="100000"/>
               </a:lnSpc>
@@ -18380,13 +18380,13 @@
               <a:buNone/>
             </a:pPr>
             <a:r>
-              <a:rPr lang="pt-BR" sz="2000" b="1" dirty="0">
+              <a:rPr lang="pt-BR" sz="1600" b="1" dirty="0">
                 <a:solidFill>
-                  <a:srgbClr val="FFFFFF"/>
+                  <a:srgbClr val="114719"/>
                 </a:solidFill>
                 <a:latin typeface="Montserrat"/>
               </a:rPr>
-              <a:t>PRELIMINAR: diagnóstico em auditoria</a:t>
+              <a:t>Nada disso mostra que a bolsa reduz o preenchimento: o corte junta a bolsa com outras regras.</a:t>
             </a:r>
           </a:p>
         </p:txBody>
@@ -18399,8 +18399,8 @@
         </p:nvSpPr>
         <p:spPr>
           <a:xfrm>
-            <a:off x="7406640" y="804672"/>
-            <a:ext cx="4480560" cy="1652016"/>
+            <a:off x="7315200" y="804672"/>
+            <a:ext cx="4572000" cy="2280310"/>
           </a:xfrm>
           <a:prstGeom prst="roundRect">
             <a:avLst>
@@ -18441,7 +18441,7 @@
                 </a:solidFill>
                 <a:latin typeface="Montserrat"/>
               </a:rPr>
-              <a:t>Sem a reta:</a:t>
+              <a:t>É a estimativa no corte, não os dados:</a:t>
             </a:r>
             <a:r>
               <a:rPr lang="pt-BR" sz="1600" b="0" dirty="0">
@@ -18450,7 +18450,7 @@
                 </a:solidFill>
                 <a:latin typeface="Montserrat"/>
               </a:rPr>
-              <a:t> a fração preenchida é praticamente igual dos dois lados (33,3% e 33,5%); a queda aparece quando a reta é levada até o corte e depende de poucos municípios.</a:t>
+              <a:t> nas médias da janela, 33,3% das células são preenchidas abaixo e 33,5% acima; a queda vem da reta levada até o corte, com poucos municípios. O acaso não está descartado.</a:t>
             </a:r>
           </a:p>
         </p:txBody>
@@ -18463,8 +18463,8 @@
         </p:nvSpPr>
         <p:spPr>
           <a:xfrm>
-            <a:off x="7406640" y="2621280"/>
-            <a:ext cx="4480560" cy="2212035"/>
+            <a:off x="7315200" y="3249574"/>
+            <a:ext cx="4572000" cy="2840330"/>
           </a:xfrm>
           <a:prstGeom prst="roundRect">
             <a:avLst>
@@ -18505,7 +18505,7 @@
                 </a:solidFill>
                 <a:latin typeface="Montserrat"/>
               </a:rPr>
-              <a:t>O que acompanha a queda:</a:t>
+              <a:t>As vagas do lado de cima eram diferentes:</a:t>
             </a:r>
             <a:r>
               <a:rPr lang="pt-BR" sz="1600" b="0" dirty="0">
@@ -18514,78 +18514,14 @@
                 </a:solidFill>
                 <a:latin typeface="Montserrat"/>
               </a:rPr>
-              <a:t> mais células só de cadastro reserva, cursos que preenchem pouco em qualquer lugar, menos células escolhidas em 1º lugar. Igualar esses fatores corta a queda pela metade ou mais em parte das medidas.</a:t>
+              <a:t> cursos que preenchem pouco em qualquer lugar, mais células do mesmo curso na mesma UF disputando candidatos e, no ciclo 2, mais células só de reserva. Igualando esses fatores, a queda diminui pela metade ou mais em parte das medidas, mas nenhum fator faz isso nas três.</a:t>
             </a:r>
           </a:p>
         </p:txBody>
       </p:sp>
       <p:sp>
         <p:nvSpPr>
-          <p:cNvPr id="105" name="Linha"/>
-          <p:cNvSpPr/>
-          <p:nvPr/>
-        </p:nvSpPr>
-        <p:spPr>
-          <a:xfrm>
-            <a:off x="7406640" y="4997907"/>
-            <a:ext cx="4480560" cy="1091997"/>
-          </a:xfrm>
-          <a:prstGeom prst="roundRect">
-            <a:avLst>
-              <a:gd name="adj" fmla="val 6000"/>
-            </a:avLst>
-          </a:prstGeom>
-          <a:solidFill>
-            <a:srgbClr val="F4F8F5"/>
-          </a:solidFill>
-          <a:ln w="12700">
-            <a:solidFill>
-              <a:srgbClr val="056429"/>
-            </a:solidFill>
-          </a:ln>
-        </p:spPr>
-        <p:txBody>
-          <a:bodyPr wrap="square" lIns="182880" tIns="54864" rIns="182880" bIns="54864" rtlCol="0" anchor="ctr">
-            <a:noAutofit/>
-          </a:bodyPr>
-          <a:lstStyle/>
-          <a:p>
-            <a:pPr marL="0" indent="0" algn="l">
-              <a:lnSpc>
-                <a:spcPct val="100000"/>
-              </a:lnSpc>
-              <a:spcBef>
-                <a:spcPts val="0"/>
-              </a:spcBef>
-              <a:spcAft>
-                <a:spcPts val="0"/>
-              </a:spcAft>
-              <a:buNone/>
-            </a:pPr>
-            <a:r>
-              <a:rPr lang="pt-BR" sz="1600" b="1" dirty="0">
-                <a:solidFill>
-                  <a:srgbClr val="114719"/>
-                </a:solidFill>
-                <a:latin typeface="Montserrat"/>
-              </a:rPr>
-              <a:t>Leitura:</a:t>
-            </a:r>
-            <a:r>
-              <a:rPr lang="pt-BR" sz="1600" b="0" dirty="0">
-                <a:solidFill>
-                  <a:srgbClr val="3A3A3A"/>
-                </a:solidFill>
-                <a:latin typeface="Montserrat"/>
-              </a:rPr>
-              <a:t> acaso não está descartado; nada mostra que a bolsa reduz o preenchimento.</a:t>
-            </a:r>
-          </a:p>
-        </p:txBody>
-      </p:sp>
-      <p:sp>
-        <p:nvSpPr>
-          <p:cNvPr id="106" name="Fontes"/>
+          <p:cNvPr id="105" name="Fontes"/>
           <p:cNvSpPr txBox="1"/>
           <p:nvPr/>
         </p:nvSpPr>
@@ -18636,7 +18572,7 @@
                 </a:solidFill>
                 <a:latin typeface="Montserrat"/>
               </a:rPr>
-              <a:t>output/rdd_bolsa/DQ_estimativas.csv, DQ_resumo.json e DQ_figuras/DQ_quanto_da_queda.png (protocolo 61; doc 57l, em auditoria); figura sem redesenho, conferida pelo hash.</a:t>
+              <a:t>output/rdd_bolsa/DQ_estimativas.csv, DQ_resumo.json e DQ_figuras/DQ_quanto_da_queda.png (protocolo 61; doc 57l; auditoria 33, §8); figura usada sem redesenho, conferida pelo hash.</a:t>
             </a:r>
           </a:p>
         </p:txBody>
@@ -19977,8 +19913,8 @@
         </p:blipFill>
         <p:spPr>
           <a:xfrm>
-            <a:off x="292608" y="1190407"/>
-            <a:ext cx="8028432" cy="4513763"/>
+            <a:off x="292608" y="804672"/>
+            <a:ext cx="7688911" cy="4322877"/>
           </a:xfrm>
           <a:prstGeom prst="rect">
             <a:avLst/>
@@ -19992,14 +19928,67 @@
       </p:pic>
       <p:sp>
         <p:nvSpPr>
-          <p:cNvPr id="102" name="Linha"/>
+          <p:cNvPr id="102" name="Cautela"/>
           <p:cNvSpPr/>
           <p:nvPr/>
         </p:nvSpPr>
         <p:spPr>
           <a:xfrm>
-            <a:off x="8595360" y="804672"/>
-            <a:ext cx="3291840" cy="1745353"/>
+            <a:off x="292608" y="5292141"/>
+            <a:ext cx="7688911" cy="797763"/>
+          </a:xfrm>
+          <a:prstGeom prst="roundRect">
+            <a:avLst>
+              <a:gd name="adj" fmla="val 8000"/>
+            </a:avLst>
+          </a:prstGeom>
+          <a:solidFill>
+            <a:srgbClr val="E7F1EA"/>
+          </a:solidFill>
+          <a:ln>
+            <a:noFill/>
+          </a:ln>
+        </p:spPr>
+        <p:txBody>
+          <a:bodyPr wrap="square" lIns="182880" tIns="54864" rIns="182880" bIns="54864" rtlCol="0" anchor="ctr">
+            <a:noAutofit/>
+          </a:bodyPr>
+          <a:lstStyle/>
+          <a:p>
+            <a:pPr marL="0" indent="0" algn="l">
+              <a:lnSpc>
+                <a:spcPct val="100000"/>
+              </a:lnSpc>
+              <a:spcBef>
+                <a:spcPts val="0"/>
+              </a:spcBef>
+              <a:spcAft>
+                <a:spcPts val="0"/>
+              </a:spcAft>
+              <a:buNone/>
+            </a:pPr>
+            <a:r>
+              <a:rPr lang="pt-BR" sz="1600" b="1" dirty="0">
+                <a:solidFill>
+                  <a:srgbClr val="114719"/>
+                </a:solidFill>
+                <a:latin typeface="Montserrat"/>
+              </a:rPr>
+              <a:t>Pós-resultado; o peso da origem é preferência revelada, não efeito causal.</a:t>
+            </a:r>
+          </a:p>
+        </p:txBody>
+      </p:sp>
+      <p:sp>
+        <p:nvSpPr>
+          <p:cNvPr id="103" name="Linha"/>
+          <p:cNvSpPr/>
+          <p:nvPr/>
+        </p:nvSpPr>
+        <p:spPr>
+          <a:xfrm>
+            <a:off x="8255839" y="804672"/>
+            <a:ext cx="3631361" cy="2186432"/>
           </a:xfrm>
           <a:prstGeom prst="roundRect">
             <a:avLst>
@@ -20056,14 +20045,14 @@
       </p:sp>
       <p:sp>
         <p:nvSpPr>
-          <p:cNvPr id="103" name="Linha"/>
+          <p:cNvPr id="104" name="Linha"/>
           <p:cNvSpPr/>
           <p:nvPr/>
         </p:nvSpPr>
         <p:spPr>
           <a:xfrm>
-            <a:off x="8595360" y="2714617"/>
-            <a:ext cx="3291840" cy="1745353"/>
+            <a:off x="8255839" y="3155696"/>
+            <a:ext cx="3631361" cy="2186432"/>
           </a:xfrm>
           <a:prstGeom prst="roundRect">
             <a:avLst>
@@ -20114,59 +20103,6 @@
                 <a:latin typeface="Montserrat"/>
               </a:rPr>
               <a:t> 0,42 [−0,03; 0,87]; a mesma UF de origem, 2,40 [2,28; 2,53]; a diferença, 1,98 [1,56; 2,40].</a:t>
-            </a:r>
-          </a:p>
-        </p:txBody>
-      </p:sp>
-      <p:sp>
-        <p:nvSpPr>
-          <p:cNvPr id="104" name="Cautela"/>
-          <p:cNvSpPr/>
-          <p:nvPr/>
-        </p:nvSpPr>
-        <p:spPr>
-          <a:xfrm>
-            <a:off x="8595360" y="4624561"/>
-            <a:ext cx="3291840" cy="1465343"/>
-          </a:xfrm>
-          <a:prstGeom prst="roundRect">
-            <a:avLst>
-              <a:gd name="adj" fmla="val 8000"/>
-            </a:avLst>
-          </a:prstGeom>
-          <a:solidFill>
-            <a:srgbClr val="E7F1EA"/>
-          </a:solidFill>
-          <a:ln>
-            <a:noFill/>
-          </a:ln>
-        </p:spPr>
-        <p:txBody>
-          <a:bodyPr wrap="square" lIns="182880" tIns="54864" rIns="182880" bIns="54864" rtlCol="0" anchor="ctr">
-            <a:noAutofit/>
-          </a:bodyPr>
-          <a:lstStyle/>
-          <a:p>
-            <a:pPr marL="0" indent="0" algn="l">
-              <a:lnSpc>
-                <a:spcPct val="100000"/>
-              </a:lnSpc>
-              <a:spcBef>
-                <a:spcPts val="0"/>
-              </a:spcBef>
-              <a:spcAft>
-                <a:spcPts val="0"/>
-              </a:spcAft>
-              <a:buNone/>
-            </a:pPr>
-            <a:r>
-              <a:rPr lang="pt-BR" sz="1600" b="1" dirty="0">
-                <a:solidFill>
-                  <a:srgbClr val="114719"/>
-                </a:solidFill>
-                <a:latin typeface="Montserrat"/>
-              </a:rPr>
-              <a:t>Pós-resultado; o peso da origem é preferência revelada, não efeito causal.</a:t>
             </a:r>
           </a:p>
         </p:txBody>
@@ -22069,8 +22005,8 @@
         </p:blipFill>
         <p:spPr>
           <a:xfrm>
-            <a:off x="292608" y="1031635"/>
-            <a:ext cx="8211312" cy="4831307"/>
+            <a:off x="292608" y="804672"/>
+            <a:ext cx="7823088" cy="4602886"/>
           </a:xfrm>
           <a:prstGeom prst="rect">
             <a:avLst/>
@@ -22084,14 +22020,67 @@
       </p:pic>
       <p:sp>
         <p:nvSpPr>
-          <p:cNvPr id="102" name="Linha"/>
+          <p:cNvPr id="102" name="Cautela"/>
           <p:cNvSpPr/>
           <p:nvPr/>
         </p:nvSpPr>
         <p:spPr>
           <a:xfrm>
-            <a:off x="8778240" y="804672"/>
-            <a:ext cx="3108960" cy="1906422"/>
+            <a:off x="292608" y="5572150"/>
+            <a:ext cx="7823088" cy="517754"/>
+          </a:xfrm>
+          <a:prstGeom prst="roundRect">
+            <a:avLst>
+              <a:gd name="adj" fmla="val 8000"/>
+            </a:avLst>
+          </a:prstGeom>
+          <a:solidFill>
+            <a:srgbClr val="E7F1EA"/>
+          </a:solidFill>
+          <a:ln>
+            <a:noFill/>
+          </a:ln>
+        </p:spPr>
+        <p:txBody>
+          <a:bodyPr wrap="square" lIns="182880" tIns="54864" rIns="182880" bIns="54864" rtlCol="0" anchor="ctr">
+            <a:noAutofit/>
+          </a:bodyPr>
+          <a:lstStyle/>
+          <a:p>
+            <a:pPr marL="0" indent="0" algn="l">
+              <a:lnSpc>
+                <a:spcPct val="100000"/>
+              </a:lnSpc>
+              <a:spcBef>
+                <a:spcPts val="0"/>
+              </a:spcBef>
+              <a:spcAft>
+                <a:spcPts val="0"/>
+              </a:spcAft>
+              <a:buNone/>
+            </a:pPr>
+            <a:r>
+              <a:rPr lang="pt-BR" sz="1600" b="1" dirty="0">
+                <a:solidFill>
+                  <a:srgbClr val="114719"/>
+                </a:solidFill>
+                <a:latin typeface="Montserrat"/>
+              </a:rPr>
+              <a:t>Associação, não efeito da bolsa; horas cadastradas não são presença.</a:t>
+            </a:r>
+          </a:p>
+        </p:txBody>
+      </p:sp>
+      <p:sp>
+        <p:nvSpPr>
+          <p:cNvPr id="103" name="Linha"/>
+          <p:cNvSpPr/>
+          <p:nvPr/>
+        </p:nvSpPr>
+        <p:spPr>
+          <a:xfrm>
+            <a:off x="8390016" y="804672"/>
+            <a:ext cx="3497184" cy="1906422"/>
           </a:xfrm>
           <a:prstGeom prst="roundRect">
             <a:avLst>
@@ -22142,59 +22131,6 @@
                 <a:latin typeface="Montserrat"/>
               </a:rPr>
               <a:t> +6,6 h/sem [+5,4; +7,8] depois da entrada, sobretudo no município do posto.</a:t>
-            </a:r>
-          </a:p>
-        </p:txBody>
-      </p:sp>
-      <p:sp>
-        <p:nvSpPr>
-          <p:cNvPr id="103" name="Cautela"/>
-          <p:cNvSpPr/>
-          <p:nvPr/>
-        </p:nvSpPr>
-        <p:spPr>
-          <a:xfrm>
-            <a:off x="8778240" y="2875686"/>
-            <a:ext cx="3108960" cy="1906422"/>
-          </a:xfrm>
-          <a:prstGeom prst="roundRect">
-            <a:avLst>
-              <a:gd name="adj" fmla="val 8000"/>
-            </a:avLst>
-          </a:prstGeom>
-          <a:solidFill>
-            <a:srgbClr val="E7F1EA"/>
-          </a:solidFill>
-          <a:ln>
-            <a:noFill/>
-          </a:ln>
-        </p:spPr>
-        <p:txBody>
-          <a:bodyPr wrap="square" lIns="182880" tIns="54864" rIns="182880" bIns="54864" rtlCol="0" anchor="ctr">
-            <a:noAutofit/>
-          </a:bodyPr>
-          <a:lstStyle/>
-          <a:p>
-            <a:pPr marL="0" indent="0" algn="l">
-              <a:lnSpc>
-                <a:spcPct val="100000"/>
-              </a:lnSpc>
-              <a:spcBef>
-                <a:spcPts val="0"/>
-              </a:spcBef>
-              <a:spcAft>
-                <a:spcPts val="0"/>
-              </a:spcAft>
-              <a:buNone/>
-            </a:pPr>
-            <a:r>
-              <a:rPr lang="pt-BR" sz="1600" b="1" dirty="0">
-                <a:solidFill>
-                  <a:srgbClr val="114719"/>
-                </a:solidFill>
-                <a:latin typeface="Montserrat"/>
-              </a:rPr>
-              <a:t>Associação, não efeito da bolsa; horas cadastradas não são presença.</a:t>
             </a:r>
           </a:p>
         </p:txBody>

</xml_diff>

<commit_message>
Deck da banca 2, slide 5: equação formal do logit condicional na tela (rubrica: Modelo); teste e mapa do grupo atualizados
Co-Authored-By: Claude Opus 5.5 <noreply@anthropic.com>
Claude-Session: https://claude.ai/code/session_011jPV4G6BtUxSX71P3Fzkr7
</commit_message>
<xml_diff>
--- a/output/apresentacao_banca2/deck_banca2_curto.pptx
+++ b/output/apresentacao_banca2/deck_banca2_curto.pptx
@@ -17406,7 +17406,7 @@
                 </a:solidFill>
                 <a:latin typeface="Montserrat"/>
               </a:rPr>
-              <a:t>chance da 1ª opção = bolsa + distância + origem</a:t>
+              <a:t>U = β·bolsa + γ·distância + θ·origem; P(j) = e^Uj/Σe^U</a:t>
             </a:r>
           </a:p>
         </p:txBody>
@@ -17730,7 +17730,7 @@
                 </a:solidFill>
                 <a:latin typeface="Montserrat"/>
               </a:rPr>
-              <a:t>D_UF = origem − bolsa &gt; zero; cluster por conjunto</a:t>
+              <a:t>D_UF = θ − 10β &gt; zero; cluster por conjunto</a:t>
             </a:r>
           </a:p>
         </p:txBody>

</xml_diff>

<commit_message>
Deck banca 2: equação do slide 6 em duas linhas (quebra no "; "), sem corte no meio
Co-Authored-By: Claude Opus 5.5 <noreply@anthropic.com>
Claude-Session: https://claude.ai/code/session_011jPV4G6BtUxSX71P3Fzkr7
</commit_message>
<xml_diff>
--- a/output/apresentacao_banca2/deck_banca2_curto.pptx
+++ b/output/apresentacao_banca2/deck_banca2_curto.pptx
@@ -17781,13 +17781,36 @@
               <a:buNone/>
             </a:pPr>
             <a:r>
-              <a:rPr lang="pt-BR" sz="2800" b="0" dirty="0">
+              <a:rPr lang="pt-BR" sz="2600" b="0" dirty="0">
                 <a:solidFill>
                   <a:srgbClr val="FFFFFF"/>
                 </a:solidFill>
                 <a:latin typeface="Montserrat"/>
               </a:rPr>
-              <a:t>U = β·bolsa + γ·distância + EF(UF origem × UF vaga) + …; P(j) = e^Uj/Σe^U</a:t>
+              <a:t>U = β·bolsa + γ·distância + EF(UF origem × UF vaga) + …;</a:t>
+            </a:r>
+          </a:p>
+          <a:p>
+            <a:pPr marL="0" indent="0" algn="ctr">
+              <a:lnSpc>
+                <a:spcPct val="100000"/>
+              </a:lnSpc>
+              <a:spcBef>
+                <a:spcPts val="0"/>
+              </a:spcBef>
+              <a:spcAft>
+                <a:spcPts val="0"/>
+              </a:spcAft>
+              <a:buNone/>
+            </a:pPr>
+            <a:r>
+              <a:rPr lang="pt-BR" sz="2600" b="0" dirty="0">
+                <a:solidFill>
+                  <a:srgbClr val="FFFFFF"/>
+                </a:solidFill>
+                <a:latin typeface="Montserrat"/>
+              </a:rPr>
+              <a:t>P(j) = e^Uj/Σe^U</a:t>
             </a:r>
           </a:p>
         </p:txBody>

</xml_diff>

<commit_message>
Deck banca 2: leitura simples do resultado principal (por +R$ 5 mil, o médico aceita vaga 75 km mais longe)
Slide 8 troca 'Em km: vale 75 km a menos' pela leitura em palavras; o x1,90 do
ciclo 2 fica na figura e nas notas para caber em 30 palavras. Roteiro e mapa
(doc 10) atualizados; números lidos do registro, como antes.

Co-Authored-By: Claude Opus 5.5 <noreply@anthropic.com>
Claude-Session: https://claude.ai/code/session_011jPV4G6BtUxSX71P3Fzkr7
</commit_message>
<xml_diff>
--- a/output/apresentacao_banca2/deck_banca2_curto.pptx
+++ b/output/apresentacao_banca2/deck_banca2_curto.pptx
@@ -9268,7 +9268,7 @@
           <a:p>
             <a:r>
               <a:rPr lang="pt-BR" dirty="0"/>
-              <a:t>FALA (0:50): Este é o resultado principal. Comparando só vagas da mesma UF, a de origem ou outra, vistas por médicos da mesma UF de origem, a vaga com bolsa R$ 5 mil maior tem 1,47 vez a chance de ser a 1ª opção, nos ciclos 1 a 3 juntos; o intervalo vai de 1,15 a 1,89. No ciclo 2, 1,90. Em km: na escolha, R$ 5 mil a mais valem o mesmo que 75 km a menos de distância. Duas ressalvas, na tela: é uma especificação escolhida depois do resultado; e a pré-registrada, sem fixar a UF, tem intervalo que contém 1.</a:t>
+              <a:t>FALA (0:50): Este é o resultado principal. Comparando só vagas da mesma UF, a de origem ou outra, vistas por médicos da mesma UF de origem, a vaga com bolsa R$ 5 mil maior tem 1,47 vez a chance de ser a 1ª opção, nos ciclos 1 a 3 juntos; o intervalo vai de 1,15 a 1,89. No ciclo 2, 1,90. Em palavras: entre duas vagas parecidas da mesma UF, a de bolsa maior tem cerca de uma vez e meia a chance de ser a escolhida; ou, por R$ 5 mil a mais, o médico aceita uma vaga 75 km mais longe. Duas ressalvas, na tela: é uma especificação escolhida depois do resultado; e a pré-registrada, sem fixar a UF, tem intervalo que contém 1.</a:t>
             </a:r>
           </a:p>
           <a:p>
@@ -19353,7 +19353,7 @@
                 </a:solidFill>
                 <a:latin typeface="Montserrat"/>
               </a:rPr>
-              <a:t>Mesma UF, +R$ 5 mil:</a:t>
+              <a:t>+R$ 5 mil:</a:t>
             </a:r>
             <a:r>
               <a:rPr lang="pt-BR" sz="1800" b="0" dirty="0">
@@ -19362,7 +19362,7 @@
                 </a:solidFill>
                 <a:latin typeface="Montserrat"/>
               </a:rPr>
-              <a:t> chance ×1,47 [1,15; 1,89]; ciclo 2: ×1,90.</a:t>
+              <a:t> chance ×1,47 [1,15; 1,89].</a:t>
             </a:r>
           </a:p>
         </p:txBody>
@@ -19411,7 +19411,7 @@
                 </a:solidFill>
                 <a:latin typeface="Montserrat"/>
               </a:rPr>
-              <a:t>Em km:</a:t>
+              <a:t>Leitura:</a:t>
             </a:r>
             <a:r>
               <a:rPr lang="pt-BR" sz="1800" b="0" dirty="0">
@@ -19420,7 +19420,7 @@
                 </a:solidFill>
                 <a:latin typeface="Montserrat"/>
               </a:rPr>
-              <a:t> vale 75 km a menos.</a:t>
+              <a:t> por +R$ 5 mil, o médico aceita vaga 75 km mais longe.</a:t>
             </a:r>
           </a:p>
         </p:txBody>

</xml_diff>

<commit_message>
Deck banca 2: robustez de inferência na tela (score bootstrap, p 0,011) no slide 9
Novos códigos VL1_EMP_PSR e VL1_C2_PSR, lidos de VL_estimativas.csv
(p_score_rademacher, adendo 52e, auditoria 48); nada reestimado.

Co-Authored-By: Claude Opus 5.5 <noreply@anthropic.com>
Claude-Session: https://claude.ai/code/session_011jPV4G6BtUxSX71P3Fzkr7
</commit_message>
<xml_diff>
--- a/output/apresentacao_banca2/deck_banca2_curto.pptx
+++ b/output/apresentacao_banca2/deck_banca2_curto.pptx
@@ -9339,13 +9339,13 @@
           <a:p>
             <a:r>
               <a:rPr lang="pt-BR" dirty="0"/>
-              <a:t>FALA (0:40): A robustez fica sempre dentro da mesma UF. À esquerda, o peso da bolsa se mantém com a distância em log e com a região de saúde de origem no lugar da UF de origem. Só com vagas perto do corte, o intervalo contém 1: inconclusivo. À direita, ciclo a ciclo: o efeito é forte só no ciclo 2; nos ciclos 1 e 3, o intervalo contém 1. Por que o ciclo 2? Não sabemos.</a:t>
+              <a:t>FALA (0:40): A robustez fica sempre dentro da mesma UF. À esquerda, o peso da bolsa se mantém com a distância em log e com a região de saúde de origem no lugar da UF de origem. Com poucos grupos, o p do score bootstrap continua 0,011. Só com vagas perto do corte, o intervalo contém 1: inconclusivo. À direita, ciclo a ciclo: o efeito é forte só no ciclo 2; nos ciclos 1 e 3, o intervalo contém 1. Por que o ciclo 2? Não sabemos.</a:t>
             </a:r>
           </a:p>
           <a:p>
             <a:r>
               <a:rPr lang="pt-BR" dirty="0"/>
-              <a:t>DETALHE PARA PERGUNTAS: Todas as variantes comparam vagas da mesma UF. Ciclos 1–3 (adendo 52e; doc 57x; auditoria 48): VL-1, 1,47 [1,15; 1,89]; com a distância em log, 1,45 [1,15; 1,83] (ciclo 2: 1,75 [1,23; 2,49]); com o efeito fixo de região de saúde de origem × UF da vaga (VL-3), 1,49 [1,15; 1,92] (ciclo 2: 1,91 [1,33; 2,74]); só com vagas a até 0,050 de um corte (VL-2), 1,28 [0,95; 1,72], p de Holm 0,103: inconclusivo, a comparação local tem pouca informação. Por ciclo, com o par de UFs fixado (adendo 52g; doc 57z; pós-resultado; auditoria pendente): ciclo 1, 1,15 [0,66; 2,01], com 16 conjuntos de escolha; ciclo 2, 1,90 [1,30; 2,78]; ciclo 3, 1,25 [0,90; 1,73], com 23 conjuntos. A leitura fixada no adendo antes de rodar: forte só no ciclo 2, como na especificação base. Os km dos ciclos 1 e 3 têm IC que contém zero e não são usados. Por que o ciclo 2, não sabemos (leituras candidatas, sem teste: informação sobre a grade, vagas por curso, parte de vagas imediatas; doc 57a). Tudo pós-resultado e condicional a se candidatar; pacote do corte.</a:t>
+              <a:t>DETALHE PARA PERGUNTAS: Todas as variantes comparam vagas da mesma UF. Ciclos 1–3 (adendo 52e; doc 57x; auditoria 48): VL-1, 1,47 [1,15; 1,89]; com a distância em log, 1,45 [1,15; 1,83] (ciclo 2: 1,75 [1,23; 2,49]); com o efeito fixo de região de saúde de origem × UF da vaga (VL-3), 1,49 [1,15; 1,92] (ciclo 2: 1,91 [1,33; 2,74]); só com vagas a até 0,050 de um corte (VL-2), 1,28 [0,95; 1,72], p de Holm 0,103: inconclusivo, a comparação local tem pouca informação. Inferência com poucos clusters (conjuntos de escolha): p do score bootstrap de Rademacher 0,011 nos ciclos 1–3 e 0,004 no ciclo 2, sem ajuste (doc 57x). Por ciclo, com o par de UFs fixado (adendo 52g; doc 57z; pós-resultado; auditoria pendente): ciclo 1, 1,15 [0,66; 2,01], com 16 conjuntos de escolha; ciclo 2, 1,90 [1,30; 2,78]; ciclo 3, 1,25 [0,90; 1,73], com 23 conjuntos. A leitura fixada no adendo antes de rodar: forte só no ciclo 2, como na especificação base. Os km dos ciclos 1 e 3 têm IC que contém zero e não são usados. Por que o ciclo 2, não sabemos (leituras candidatas, sem teste: informação sobre a grade, vagas por curso, parte de vagas imediatas; doc 57a). Tudo pós-resultado e condicional a se candidatar; pacote do corte.</a:t>
             </a:r>
           </a:p>
         </p:txBody>
@@ -19803,7 +19803,7 @@
                 </a:solidFill>
                 <a:latin typeface="Montserrat"/>
               </a:rPr>
-              <a:t> distância em log; região de saúde × UF.</a:t>
+              <a:t> log da distância; região × UF; score bootstrap (p 0,011).</a:t>
             </a:r>
           </a:p>
         </p:txBody>

</xml_diff>

<commit_message>
Deck banca 2: nada de preenchimento, só a escolha da 1ª opção (decisão do autor, 28/10)
Saem a motivação pelo preenchimento no corte (slide 1 passa a 'a bolsa sobe com
o IVS'), a limitação 'escolha ≠ preenchimento' (vira 'sem margem extensiva') e o
apêndice com o fato da antiga H1; o deck fica com 11 slides. Roteiro (doc 09),
mapa do grupo (doc 10, §6.6), docs 07 e 08 e testes atualizados; novo teste
barra 'preench' no doc 04 e na tela e nas notas do pptx. Nada reestimado.

Co-Authored-By: Claude Opus 5.5 <noreply@anthropic.com>
Claude-Session: https://claude.ai/code/session_011jPV4G6BtUxSX71P3Fzkr7
</commit_message>
<xml_diff>
--- a/output/apresentacao_banca2/deck_banca2_curto.pptx
+++ b/output/apresentacao_banca2/deck_banca2_curto.pptx
@@ -20,7 +20,6 @@
     <p:sldId id="410" r:id="rId57"/>
     <p:sldId id="411" r:id="rId58"/>
     <p:sldId id="412" r:id="rId59"/>
-    <p:sldId id="413" r:id="rId60"/>
   </p:sldIdLst>
   <p:sldSz cx="12192000" cy="6858000"/>
   <p:notesSz cx="6858000" cy="9144000"/>
@@ -8801,13 +8800,13 @@
           <a:p>
             <a:r>
               <a:rPr lang="pt-BR" dirty="0"/>
-              <a:t>FALA (0:35): Nossa pergunta é simples: quando o médico especialista escolhe uma vaga do PMM-E, a bolsa maior muda qual vaga ele põe em 1ª opção? A hipótese: comparando vagas da mesma UF, a vaga de bolsa maior tem mais chance de ser a 1ª opção. A motivação vem do corte de IVS: onde a bolsa é R$ 5 mil maior, não detectamos aumento do preenchimento; então olhamos um passo antes, a escolha. Um aviso honesto, que está na tela: formulamos esta hipótese depois de ver os dados.</a:t>
+              <a:t>FALA (0:35): Nossa pergunta é simples: quando o médico especialista escolhe uma vaga do PMM-E, a bolsa maior muda qual vaga ele põe em 1ª opção? A hipótese: comparando vagas da mesma UF, a vaga de bolsa maior tem mais chance de ser a 1ª opção. A motivação: o programa paga bolsa maior onde o IVS do município é maior; queremos saber se isso muda a vaga que o médico escolhe. Um aviso honesto, que está na tela: formulamos esta hipótese depois de ver os dados.</a:t>
             </a:r>
           </a:p>
           <a:p>
             <a:r>
               <a:rPr lang="pt-BR" dirty="0"/>
-              <a:t>DETALHE PARA PERGUNTAS: Hipótese única desta versão (decisão do autor de 28/10/2026; doc 07 da banca 2): "a hipótese é simplesmente sobre o efeito bolsa → 1ª opção", com "só comparação entre municípios da mesma UF". A UF de origem, a UF da vaga, a região de saúde, o município e a distância entram só como controle e pareamento, nunca como resultado. Foi formulada depois de ver os resultados do preenchimento no corte e os coeficientes do modelo de escolha: é pós-resultado, e isso é dito aqui. Motivação: onde a bolsa é R$ 5 mil maior, não detectamos aumento do preenchimento comparando municípios pareados na mesma UF (apêndice). Ligar a hipótese a esse fato é interpretação, não teste (auditoria 50). O contraste da bolsa é o pacote do corte (a bolsa e as outras regras federais que mudam nos mesmos cortes de IVS, auditoria 18), não a participação no PMM-E nem o Agora Tem Especialistas. Tudo é condicional a se candidatar.</a:t>
+              <a:t>DETALHE PARA PERGUNTAS: Hipótese única desta versão (decisão do autor de 28/10/2026; doc 07 da banca 2): "a hipótese é simplesmente sobre o efeito bolsa → 1ª opção", com "só comparação entre municípios da mesma UF". A UF de origem, a UF da vaga, a região de saúde, o município e a distância entram só como controle e pareamento, nunca como resultado. Foi formulada depois de ver outros resultados do projeto no corte e os coeficientes do modelo de escolha: é pós-resultado, e isso é dito aqui. A leitura pela teoria da banca 1 é interpretação, não teste (auditoria 50). O contraste da bolsa é o pacote do corte (a bolsa e as outras regras federais que mudam nos mesmos cortes de IVS, auditoria 18), não a participação no PMM-E nem o Agora Tem Especialistas. Tudo é condicional a se candidatar.</a:t>
             </a:r>
           </a:p>
           <a:p>
@@ -9404,13 +9403,13 @@
           <a:p>
             <a:r>
               <a:rPr lang="pt-BR" dirty="0"/>
-              <a:t>FALA (0:35): Voltando à pergunta: a bolsa maior aumenta a chance de a vaga ser a 1ª opção, comparando vagas da mesma UF? Sim: 1,47 vez a chance nos três ciclos juntos, e forte só no ciclo 2. Pela teoria da banca 1, o médico aceita a vaga se a bolsa compensa o custo do lugar; os dados sugerem que R$ 5 mil compensam parte desse custo, cerca de 75 km a menos. Isso vale para a escolha de quem se candidatou, não para o preenchimento.</a:t>
+              <a:t>FALA (0:35): Voltando à pergunta: a bolsa maior aumenta a chance de a vaga ser a 1ª opção, comparando vagas da mesma UF? Sim: 1,47 vez a chance nos três ciclos juntos, e forte só no ciclo 2. Pela teoria da banca 1, o médico aceita a vaga se a bolsa compensa o custo do lugar; os dados sugerem que R$ 5 mil compensam parte desse custo, cerca de 75 km a menos. Isso vale para a escolha de quem se candidatou.</a:t>
             </a:r>
           </a:p>
           <a:p>
             <a:r>
               <a:rPr lang="pt-BR" dirty="0"/>
-              <a:t>DETALHE PARA PERGUNTAS: No modelo da banca 1, o médico aceita a vaga se a bolsa compensa o custo do lugar. O dado: comparando vagas da mesma UF, a vaga de bolsa maior tem mais chance de ser a 1ª opção. A leitura que os dados sugerem, sem teste direto: a bolsa compensa parte do custo do lugar, e R$ 5 mil valem cerca de 75 km a menos de distância na escolha. É interpretação, não teste (auditoria 50). Não testamos se isso aumenta o preenchimento; no corte, comparando municípios pareados na mesma UF, não detectamos aumento (apêndice). Dá para afirmar: entre quem se candidatou, a vaga de bolsa maior é preferida a uma vaga parecida da mesma UF, com força só no ciclo 2 (nos ciclos 1 e 3, separados, o IC contém 1). Não dá para afirmar: que a bolsa causa mais médicos no município; que o efeito no preenchimento é zero; que a bolsa reduz o preenchimento; que o efeito vale fora do pacote do corte. O contraste é o pacote do corte, não a participação no PMM-E. Próximos passos: a auditoria do adendo 52g, o ciclo 3 com a competência 202703 madura e o universo de inscritos.</a:t>
+              <a:t>DETALHE PARA PERGUNTAS: No modelo da banca 1, o médico aceita a vaga se a bolsa compensa o custo do lugar. O dado: comparando vagas da mesma UF, a vaga de bolsa maior tem mais chance de ser a 1ª opção. A leitura que os dados sugerem, sem teste direto: a bolsa compensa parte do custo do lugar, e R$ 5 mil valem cerca de 75 km a menos de distância na escolha. É interpretação, não teste (auditoria 50). Dá para afirmar: entre quem se candidatou, a vaga de bolsa maior é preferida a uma vaga parecida da mesma UF, com força só no ciclo 2 (nos ciclos 1 e 3, separados, o IC contém 1). Não dá para afirmar: que a bolsa causa mais médicos no município; nada sobre quem não se candidatou; que o efeito vale fora do pacote do corte. O contraste é o pacote do corte, não a participação no PMM-E. Próximos passos: a auditoria do adendo 52g, o ciclo 3 com a competência 202703 madura e o universo de inscritos.</a:t>
             </a:r>
           </a:p>
         </p:txBody>
@@ -9469,78 +9468,13 @@
           <a:p>
             <a:r>
               <a:rPr lang="pt-BR" dirty="0"/>
-              <a:t>FALA (0:45): Seis limitações e o que cada uma implica. A especificação é pós-resultado: o resultado é exploratório e pede dados novos. Sem fixar a UF, como no pré-registrado, o intervalo contém 1. Só vemos quem se candidatou: mudar a escolha não é mudar o preenchimento. O contraste é o pacote do corte: vale para o pacote, não para os R$ 5 mil sozinhos. O efeito é forte só no ciclo 2: não dá para generalizar. E a origem é o vínculo no CNES, não a residência. Obrigado.</a:t>
+              <a:t>FALA (0:45): Seis limitações e o que cada uma implica. A especificação é pós-resultado: o resultado é exploratório e pede dados novos. Sem fixar a UF, como no pré-registrado, o intervalo contém 1. Só vemos quem se candidatou: nada diz sobre quem não se inscreveu. O contraste é o pacote do corte: vale para o pacote, não para os R$ 5 mil sozinhos. O efeito é forte só no ciclo 2: não dá para generalizar. E a origem é o vínculo no CNES, não a residência. Obrigado.</a:t>
             </a:r>
           </a:p>
           <a:p>
             <a:r>
               <a:rPr lang="pt-BR" dirty="0"/>
-              <a:t>DETALHE PARA PERGUNTAS: Implicações, com mais detalhe. Pós-resultado: a hipótese e a especificação com o par de UFs vieram depois dos coeficientes do modelo base; o resultado é exploratório e só vira confirmatório com um protocolo congelado aplicado a dados novos (o universo de inscritos, novos ciclos). Sem fixar a UF: a especificação pré-registrada (P1a) dá 1,25 [0,98; 1,61], IC que contém 1 (p 0,072; família de um teste, Holm = p). Condicional a se candidatar: sem a margem extensiva, nada aqui diz quantos especialistas a mais se inscreveriam com bolsa maior; escolha não é preenchimento, e o que uma vaga ganha, outra do mesmo curso perde. Pacote do corte: nos mesmos cortes mudam outras regras federais (auditoria 18); a implicação de política vale para o pacote, não para os R$ 5 mil sozinhos. Só ciclo 2: comparando vagas da mesma UF, ciclo a ciclo (adendo 52g), 1,15 [0,66; 2,01] no ciclo 1 e 1,25 [0,90; 1,73] no ciclo 3, IC que contêm 1; não generalizar para o programa. Origem = vínculo no CNES: quem trabalha longe de casa aparece com a origem do trabalho; ela só define o par de UFs que fica fixo. Perguntas prováveis da banca (doc 66, §8). P1, "Vocês formularam a hipótese depois de ver os resultados?" Sim, e está na tela do slide 1; a especificação com o par de UFs foi congelada antes de rodar (52e; auditoria 48), mas depois de ver o modelo base. P2, "Se o pré-registrado tem IC que contém 1, por que acreditar?" Porque, comparando vagas da mesma UF, o efeito é 1,47 [1,15; 1,89], p de Holm 0,005, e se mantém com o score bootstrap; mas é exploratório. P3, "Isso é a bolsa ou o pacote?" O pacote do corte: nos mesmos cortes mudam outras regras federais (auditoria 18); em 0,300 nenhum outro incentivo individual ao especialista do PMM-E muda (auditoria 35); em 0,400 fica aberta a ajuda de custo do PMMB; nos dois cortes, o serviço do município pode mudar. P4, "E a origem?" Não é a pergunta desta hipótese: a UF de origem é controle. Se insistirem: no modelo base, sem fixar a UF, o teste origem × toda a bolsa (D_UF) dá 1,94 [1,48; 2,40] em log-chance (doc 57p); não é interpretado aqui.</a:t>
-            </a:r>
-          </a:p>
-        </p:txBody>
-      </p:sp>
-    </p:spTree>
-  </p:cSld>
-  <p:clrMapOvr>
-    <a:masterClrMapping/>
-  </p:clrMapOvr>
-</p:notes>
-</file>
-
-<file path=ppt/notesSlides/notesSlide34.xml><?xml version="1.0" encoding="utf-8"?>
-<p:notes xmlns:a="http://schemas.openxmlformats.org/drawingml/2006/main" xmlns:r="http://schemas.openxmlformats.org/officeDocument/2006/relationships" xmlns:p="http://schemas.openxmlformats.org/presentationml/2006/main">
-  <p:cSld>
-    <p:spTree>
-      <p:nvGrpSpPr>
-        <p:cNvPr id="1" name=""/>
-        <p:cNvGrpSpPr/>
-        <p:nvPr/>
-      </p:nvGrpSpPr>
-      <p:grpSpPr>
-        <a:xfrm>
-          <a:off x="0" y="0"/>
-          <a:ext cx="0" cy="0"/>
-          <a:chOff x="0" y="0"/>
-          <a:chExt cx="0" cy="0"/>
-        </a:xfrm>
-      </p:grpSpPr>
-      <p:sp>
-        <p:nvSpPr>
-          <p:cNvPr id="2" name="Slide Image Placeholder 1"/>
-          <p:cNvSpPr>
-            <a:spLocks noGrp="1" noRot="1" noChangeAspect="1"/>
-          </p:cNvSpPr>
-          <p:nvPr>
-            <p:ph type="sldImg"/>
-          </p:nvPr>
-        </p:nvSpPr>
-        <p:spPr/>
-      </p:sp>
-      <p:sp>
-        <p:nvSpPr>
-          <p:cNvPr id="3" name="Notes Placeholder 2"/>
-          <p:cNvSpPr>
-            <a:spLocks noGrp="1"/>
-          </p:cNvSpPr>
-          <p:nvPr>
-            <p:ph type="body" idx="1"/>
-          </p:nvPr>
-        </p:nvSpPr>
-        <p:spPr/>
-        <p:txBody>
-          <a:bodyPr/>
-          <a:lstStyle/>
-          <a:p>
-            <a:r>
-              <a:rPr lang="pt-BR" dirty="0"/>
-              <a:t>Antiga H1, só como motivação, e só com a comparação dentro da mesma UF (decisão do autor de 28/10/2026; adendo 48h, doc 57w, auditoria 47). Pareando municípios da mesma UF e condição de capital, a fração das células com vaga imediata preenchidas na 1ª chamada difere em +16,4 [−3,8; +36,6] p.p. em 0,300, com 25 pares, e −6,0 [−23,2; +11,5] em 0,400, com 29 pares (IC de permutação); o ponto não deve ser lido como tamanho de efeito. Não detectamos aumento; isso não quer dizer que o efeito seja zero, e não mostra que a bolsa reduz o preenchimento. Médico de outra UF por vaga imediata: +0,02 [−0,01; +0,06] em 0,300 e +0,16 [+0,00; +0,35] em 0,400, inconclusivo, com poucos pares. Pacote do corte.</a:t>
-            </a:r>
-          </a:p>
-          <a:p>
-            <a:r>
-              <a:rPr lang="pt-BR" dirty="0"/>
-              <a:t>Cautela na tela: Pacote do corte; poucos pares.</a:t>
+              <a:t>DETALHE PARA PERGUNTAS: Implicações, com mais detalhe. Pós-resultado: a hipótese e a especificação com o par de UFs vieram depois dos coeficientes do modelo base; o resultado é exploratório e só vira confirmatório com um protocolo congelado aplicado a dados novos (o universo de inscritos, novos ciclos). Sem fixar a UF: a especificação pré-registrada (P1a) dá 1,25 [0,98; 1,61], IC que contém 1 (p 0,072; família de um teste, Holm = p). Condicional a se candidatar: sem a margem extensiva, nada aqui diz quantos especialistas a mais se inscreveriam com bolsa maior; e o que uma vaga ganha na escolha, outra do mesmo curso perde. Pacote do corte: nos mesmos cortes mudam outras regras federais (auditoria 18); a implicação de política vale para o pacote, não para os R$ 5 mil sozinhos. Só ciclo 2: comparando vagas da mesma UF, ciclo a ciclo (adendo 52g), 1,15 [0,66; 2,01] no ciclo 1 e 1,25 [0,90; 1,73] no ciclo 3, IC que contêm 1; não generalizar para o programa. Origem = vínculo no CNES: quem trabalha longe de casa aparece com a origem do trabalho; ela só define o par de UFs que fica fixo. Perguntas prováveis da banca (doc 66, §8). P1, "Vocês formularam a hipótese depois de ver os resultados?" Sim, e está na tela do slide 1; a especificação com o par de UFs foi congelada antes de rodar (52e; auditoria 48), mas depois de ver o modelo base. P2, "Se o pré-registrado tem IC que contém 1, por que acreditar?" Porque, comparando vagas da mesma UF, o efeito é 1,47 [1,15; 1,89], p de Holm 0,005, e se mantém com o score bootstrap; mas é exploratório. P3, "Isso é a bolsa ou o pacote?" O pacote do corte: nos mesmos cortes mudam outras regras federais (auditoria 18); em 0,300 nenhum outro incentivo individual ao especialista do PMM-E muda (auditoria 35); em 0,400 fica aberta a ajuda de custo do PMMB; nos dois cortes, o serviço do município pode mudar. P4, "E a origem?" Não é a pergunta desta hipótese: a UF de origem é controle. Se insistirem: no modelo base, sem fixar a UF, o teste origem × toda a bolsa (D_UF) dá 1,94 [1,48; 2,40] em log-chance (doc 57p); não é interpretado aqui.</a:t>
             </a:r>
           </a:p>
         </p:txBody>
@@ -15862,7 +15796,7 @@
                 </a:solidFill>
                 <a:latin typeface="Montserrat"/>
               </a:rPr>
-              <a:t>no corte, preenchimento sem aumento detectado</a:t>
+              <a:t>a bolsa sobe com o IVS</a:t>
             </a:r>
           </a:p>
         </p:txBody>
@@ -15920,7 +15854,7 @@
                 </a:solidFill>
                 <a:latin typeface="Montserrat"/>
               </a:rPr>
-              <a:t>doc 07 da banca 2 (decisão do autor de 28/10/2026); adendos 52e e 52g; doc 57x; auditoria 48; doc 57w (apêndice).</a:t>
+              <a:t>doc 07 da banca 2 (decisão do autor de 28/10/2026); adendos 52e e 52g; doc 57x; auditoria 48.</a:t>
             </a:r>
           </a:p>
         </p:txBody>
@@ -20780,8 +20714,8 @@
             <a:tbl>
               <a:tblPr firstRow="1" bandRow="1"/>
               <a:tblGrid>
-                <a:gridCol w="4956887"/>
-                <a:gridCol w="6637705"/>
+                <a:gridCol w="5235958"/>
+                <a:gridCol w="6358634"/>
               </a:tblGrid>
               <a:tr h="732826">
                 <a:tc>
@@ -21192,7 +21126,7 @@
                           </a:solidFill>
                           <a:latin typeface="Montserrat"/>
                         </a:rPr>
-                        <a:t>escolha ≠ preenchimento</a:t>
+                        <a:t>sem margem extensiva</a:t>
                       </a:r>
                     </a:p>
                   </a:txBody>
@@ -21522,7 +21456,7 @@
                           </a:solidFill>
                           <a:latin typeface="Montserrat"/>
                         </a:rPr>
-                        <a:t>não é residência</a:t>
+                        <a:t>≠ residência</a:t>
                       </a:r>
                     </a:p>
                   </a:txBody>
@@ -21611,371 +21545,6 @@
                 <a:latin typeface="Montserrat"/>
               </a:rPr>
               <a:t>doc 66 (§0, §5 e §8); doc 07 da banca 2 (§3 e §4); docs 57p, 57x e 57z; auditorias 18, 48, 50 e 52.</a:t>
-            </a:r>
-          </a:p>
-        </p:txBody>
-      </p:sp>
-    </p:spTree>
-  </p:cSld>
-  <p:clrMapOvr>
-    <a:masterClrMapping/>
-  </p:clrMapOvr>
-</p:sld>
-</file>
-
-<file path=ppt/slides/slide48.xml><?xml version="1.0" encoding="utf-8"?>
-<p:sld xmlns:a="http://schemas.openxmlformats.org/drawingml/2006/main" xmlns:r="http://schemas.openxmlformats.org/officeDocument/2006/relationships" xmlns:p="http://schemas.openxmlformats.org/presentationml/2006/main">
-  <p:cSld>
-    <p:spTree>
-      <p:nvGrpSpPr>
-        <p:cNvPr id="1" name=""/>
-        <p:cNvGrpSpPr/>
-        <p:nvPr/>
-      </p:nvGrpSpPr>
-      <p:grpSpPr>
-        <a:xfrm>
-          <a:off x="0" y="0"/>
-          <a:ext cx="0" cy="0"/>
-          <a:chOff x="0" y="0"/>
-          <a:chExt cx="0" cy="0"/>
-        </a:xfrm>
-      </p:grpSpPr>
-      <p:sp>
-        <p:nvSpPr>
-          <p:cNvPr id="2" name="Título"/>
-          <p:cNvSpPr>
-            <a:spLocks noGrp="1"/>
-          </p:cNvSpPr>
-          <p:nvPr>
-            <p:ph type="title"/>
-          </p:nvPr>
-        </p:nvSpPr>
-        <p:spPr/>
-        <p:txBody>
-          <a:bodyPr>
-            <a:normAutofit/>
-          </a:bodyPr>
-          <a:lstStyle/>
-          <a:p>
-            <a:pPr marL="0" indent="0" algn="l">
-              <a:lnSpc>
-                <a:spcPct val="104000"/>
-              </a:lnSpc>
-              <a:spcAft>
-                <a:spcPts val="0"/>
-              </a:spcAft>
-              <a:buNone/>
-            </a:pPr>
-            <a:r>
-              <a:rPr lang="pt-BR" sz="2400" b="1" dirty="0">
-                <a:solidFill>
-                  <a:srgbClr val="FFFFFF"/>
-                </a:solidFill>
-                <a:latin typeface="Montserrat"/>
-              </a:rPr>
-              <a:t>Apêndice · O fato: pareando municípios da mesma UF</a:t>
-            </a:r>
-          </a:p>
-        </p:txBody>
-      </p:sp>
-      <p:sp>
-        <p:nvSpPr>
-          <p:cNvPr id="3" name="Número da página"/>
-          <p:cNvSpPr>
-            <a:spLocks noGrp="1"/>
-          </p:cNvSpPr>
-          <p:nvPr>
-            <p:ph type="body" sz="quarter" idx="18"/>
-          </p:nvPr>
-        </p:nvSpPr>
-        <p:spPr>
-          <a:xfrm>
-            <a:off x="11706744" y="6457042"/>
-            <a:ext cx="492080" cy="400640"/>
-          </a:xfrm>
-        </p:spPr>
-        <p:txBody>
-          <a:bodyPr anchor="ctr">
-            <a:normAutofit/>
-          </a:bodyPr>
-          <a:lstStyle/>
-          <a:p>
-            <a:pPr algn="ctr"/>
-            <a:fld id="{B1A5E0C2-5F3A-4C7E-9D11-7A2E6C0F4B01}" type="slidenum">
-              <a:rPr lang="pt-BR" sz="1400" b="1">
-                <a:solidFill>
-                  <a:srgbClr val="BFBFBF"/>
-                </a:solidFill>
-                <a:latin typeface="Montserrat"/>
-              </a:rPr>
-              <a:t>‹#›</a:t>
-            </a:fld>
-            <a:endParaRPr lang="pt-BR" sz="1400" b="1">
-              <a:solidFill>
-                <a:srgbClr val="BFBFBF"/>
-              </a:solidFill>
-            </a:endParaRPr>
-          </a:p>
-        </p:txBody>
-      </p:sp>
-      <p:sp>
-        <p:nvSpPr>
-          <p:cNvPr id="4" name="Navegação do rodapé"/>
-          <p:cNvSpPr txBox="1"/>
-          <p:nvPr/>
-        </p:nvSpPr>
-        <p:spPr>
-          <a:xfrm>
-            <a:off x="196860" y="6639248"/>
-            <a:ext cx="9223026" cy="246221"/>
-          </a:xfrm>
-          <a:prstGeom prst="rect">
-            <a:avLst/>
-          </a:prstGeom>
-          <a:noFill/>
-        </p:spPr>
-        <p:txBody>
-          <a:bodyPr wrap="square" rtlCol="0">
-            <a:spAutoFit/>
-          </a:bodyPr>
-          <a:lstStyle/>
-          <a:p>
-            <a:r>
-              <a:rPr lang="pt-BR" sz="1000" dirty="0">
-                <a:latin typeface="Montserrat"/>
-              </a:rPr>
-              <a:t xml:space="preserve">Hipótese  |  </a:t>
-            </a:r>
-            <a:r>
-              <a:rPr lang="pt-BR" sz="1000" dirty="0">
-                <a:latin typeface="Montserrat"/>
-              </a:rPr>
-              <a:t xml:space="preserve">Dados  |  </a:t>
-            </a:r>
-            <a:r>
-              <a:rPr lang="pt-BR" sz="1000" dirty="0">
-                <a:latin typeface="Montserrat"/>
-              </a:rPr>
-              <a:t xml:space="preserve">Análise descritiva  |  </a:t>
-            </a:r>
-            <a:r>
-              <a:rPr lang="pt-BR" sz="1000" dirty="0">
-                <a:latin typeface="Montserrat"/>
-              </a:rPr>
-              <a:t xml:space="preserve">Metodologia  |  </a:t>
-            </a:r>
-            <a:r>
-              <a:rPr lang="pt-BR" sz="1000" dirty="0">
-                <a:latin typeface="Montserrat"/>
-              </a:rPr>
-              <a:t xml:space="preserve">Identificação  |  </a:t>
-            </a:r>
-            <a:r>
-              <a:rPr lang="pt-BR" sz="1000" dirty="0">
-                <a:latin typeface="Montserrat"/>
-              </a:rPr>
-              <a:t xml:space="preserve">Resultados  |  </a:t>
-            </a:r>
-            <a:r>
-              <a:rPr lang="pt-BR" sz="1000" dirty="0">
-                <a:latin typeface="Montserrat"/>
-              </a:rPr>
-              <a:t xml:space="preserve">Robustez  |  </a:t>
-            </a:r>
-            <a:r>
-              <a:rPr lang="pt-BR" sz="1000" dirty="0">
-                <a:latin typeface="Montserrat"/>
-              </a:rPr>
-              <a:t xml:space="preserve">Discussão</a:t>
-            </a:r>
-          </a:p>
-        </p:txBody>
-      </p:sp>
-      <p:sp>
-        <p:nvSpPr>
-          <p:cNvPr id="101" name="Linha"/>
-          <p:cNvSpPr/>
-          <p:nvPr/>
-        </p:nvSpPr>
-        <p:spPr>
-          <a:xfrm>
-            <a:off x="292608" y="5212080"/>
-            <a:ext cx="11594592" cy="420624"/>
-          </a:xfrm>
-          <a:prstGeom prst="rect">
-            <a:avLst/>
-          </a:prstGeom>
-          <a:noFill/>
-          <a:ln>
-            <a:noFill/>
-          </a:ln>
-        </p:spPr>
-        <p:txBody>
-          <a:bodyPr wrap="square" lIns="164592" tIns="18288" rIns="164592" bIns="18288" rtlCol="0" anchor="ctr">
-            <a:noAutofit/>
-          </a:bodyPr>
-          <a:lstStyle/>
-          <a:p>
-            <a:pPr marL="0" indent="0" algn="l">
-              <a:lnSpc>
-                <a:spcPct val="100000"/>
-              </a:lnSpc>
-              <a:spcBef>
-                <a:spcPts val="0"/>
-              </a:spcBef>
-              <a:spcAft>
-                <a:spcPts val="0"/>
-              </a:spcAft>
-              <a:buNone/>
-            </a:pPr>
-            <a:r>
-              <a:rPr lang="pt-BR" sz="1800" b="0" dirty="0">
-                <a:solidFill>
-                  <a:srgbClr val="3A3A3A"/>
-                </a:solidFill>
-                <a:latin typeface="Montserrat"/>
-              </a:rPr>
-              <a:t>Sem aumento detectado do preenchimento nos dois cortes.</a:t>
-            </a:r>
-          </a:p>
-        </p:txBody>
-      </p:sp>
-      <p:sp>
-        <p:nvSpPr>
-          <p:cNvPr id="102" name="Cautela"/>
-          <p:cNvSpPr/>
-          <p:nvPr/>
-        </p:nvSpPr>
-        <p:spPr>
-          <a:xfrm>
-            <a:off x="292608" y="5687568"/>
-            <a:ext cx="11594592" cy="420624"/>
-          </a:xfrm>
-          <a:prstGeom prst="roundRect">
-            <a:avLst>
-              <a:gd name="adj" fmla="val 12000"/>
-            </a:avLst>
-          </a:prstGeom>
-          <a:solidFill>
-            <a:srgbClr val="E7F1EA"/>
-          </a:solidFill>
-          <a:ln>
-            <a:noFill/>
-          </a:ln>
-        </p:spPr>
-        <p:txBody>
-          <a:bodyPr wrap="square" lIns="164592" tIns="18288" rIns="164592" bIns="18288" rtlCol="0" anchor="ctr">
-            <a:noAutofit/>
-          </a:bodyPr>
-          <a:lstStyle/>
-          <a:p>
-            <a:pPr marL="0" indent="0" algn="l">
-              <a:lnSpc>
-                <a:spcPct val="100000"/>
-              </a:lnSpc>
-              <a:spcBef>
-                <a:spcPts val="0"/>
-              </a:spcBef>
-              <a:spcAft>
-                <a:spcPts val="0"/>
-              </a:spcAft>
-              <a:buNone/>
-            </a:pPr>
-            <a:r>
-              <a:rPr lang="pt-BR" sz="1800" b="1" dirty="0">
-                <a:solidFill>
-                  <a:srgbClr val="114719"/>
-                </a:solidFill>
-                <a:latin typeface="Montserrat"/>
-              </a:rPr>
-              <a:t>Pacote do corte; poucos pares.</a:t>
-            </a:r>
-          </a:p>
-        </p:txBody>
-      </p:sp>
-      <p:pic>
-        <p:nvPicPr>
-          <p:cNvPr id="103" name="Figura" descr="O fato, por corte: diferença no preenchimento das vagas imediatas entre municípios pareados na mesma UF e condição de capital, com IC 95% de permutação"/>
-          <p:cNvPicPr>
-            <a:picLocks noChangeAspect="1"/>
-          </p:cNvPicPr>
-          <p:nvPr/>
-        </p:nvPicPr>
-        <p:blipFill>
-          <a:blip r:embed="rId3"/>
-          <a:stretch>
-            <a:fillRect/>
-          </a:stretch>
-        </p:blipFill>
-        <p:spPr>
-          <a:xfrm>
-            <a:off x="292608" y="1577526"/>
-            <a:ext cx="11594592" cy="2733684"/>
-          </a:xfrm>
-          <a:prstGeom prst="rect">
-            <a:avLst/>
-          </a:prstGeom>
-          <a:ln w="6350">
-            <a:solidFill>
-              <a:srgbClr val="DDE7DF"/>
-            </a:solidFill>
-          </a:ln>
-        </p:spPr>
-      </p:pic>
-      <p:sp>
-        <p:nvSpPr>
-          <p:cNvPr id="104" name="Fontes"/>
-          <p:cNvSpPr txBox="1"/>
-          <p:nvPr/>
-        </p:nvSpPr>
-        <p:spPr>
-          <a:xfrm>
-            <a:off x="292608" y="6181344"/>
-            <a:ext cx="11594592" cy="274320"/>
-          </a:xfrm>
-          <a:prstGeom prst="rect">
-            <a:avLst/>
-          </a:prstGeom>
-          <a:noFill/>
-          <a:ln>
-            <a:noFill/>
-          </a:ln>
-        </p:spPr>
-        <p:txBody>
-          <a:bodyPr wrap="square" lIns="0" tIns="0" rIns="0" bIns="0" rtlCol="0" anchor="b">
-            <a:noAutofit/>
-          </a:bodyPr>
-          <a:lstStyle/>
-          <a:p>
-            <a:pPr marL="0" indent="0" algn="l">
-              <a:lnSpc>
-                <a:spcPct val="95000"/>
-              </a:lnSpc>
-              <a:spcBef>
-                <a:spcPts val="0"/>
-              </a:spcBef>
-              <a:spcAft>
-                <a:spcPts val="0"/>
-              </a:spcAft>
-              <a:buNone/>
-            </a:pPr>
-            <a:r>
-              <a:rPr lang="pt-BR" sz="800" b="1" dirty="0">
-                <a:solidFill>
-                  <a:srgbClr val="6B6B6B"/>
-                </a:solidFill>
-                <a:latin typeface="Montserrat"/>
-              </a:rPr>
-              <a:t>Fontes: </a:t>
-            </a:r>
-            <a:r>
-              <a:rPr lang="pt-BR" sz="800" b="0" dirty="0">
-                <a:solidFill>
-                  <a:srgbClr val="6B6B6B"/>
-                </a:solidFill>
-                <a:latin typeface="Montserrat"/>
-              </a:rPr>
-              <a:t>output/rdd_bolsa/PL_estimativas.csv (adendo 48h; doc 57w; auditoria 47); output/apresentacao_banca2/curto_fato_pareado.png.</a:t>
             </a:r>
           </a:p>
         </p:txBody>

</xml_diff>

<commit_message>
Deck banca 2: deixa claro que y é a 1ª opção marcada na inscrição, não a ida ao município
Cautela nova no slide 2; Limitações: 'Só inscrição: ≠ ida ao município'; fala dos
slides 2, 10 e 11 e pergunta provável no doc 09; mapa do grupo (doc 10, §6.7).

Co-Authored-By: Claude Opus 5.5 <noreply@anthropic.com>
Claude-Session: https://claude.ai/code/session_011jPV4G6BtUxSX71P3Fzkr7
</commit_message>
<xml_diff>
--- a/output/apresentacao_banca2/deck_banca2_curto.pptx
+++ b/output/apresentacao_banca2/deck_banca2_curto.pptx
@@ -8871,13 +8871,19 @@
           <a:p>
             <a:r>
               <a:rPr lang="pt-BR" dirty="0"/>
-              <a:t>FALA (0:45): A 1ª opção de cada candidato vem dos editais do Ministério da Saúde, ciclos 1 a 3; a origem vem do CNES: o município onde ele tinha vínculo médico antes da inscrição; bolsa e vagas, dos quadros de vagas; o IVS, do Ipea; distância e UF, do IBGE. A unidade de observação é o par candidato × vaga: cada candidato aparece uma vez para cada vaga aberta do seu curso e ciclo, e a variável dependente vale 1 na sua 1ª opção. O funil, à direita, mostra quem sai em cada etapa: dos 5.714 candidatos com 1ª opção, 5.421 entram no modelo.</a:t>
+              <a:t>FALA (0:45): A 1ª opção de cada candidato vem dos editais do Ministério da Saúde, ciclos 1 a 3; a origem vem do CNES: o município onde ele tinha vínculo médico antes da inscrição; bolsa e vagas, dos quadros de vagas; o IVS, do Ipea; distância e UF, do IBGE. A unidade de observação é o par candidato × vaga: cada candidato aparece uma vez para cada vaga aberta do seu curso e ciclo, e a variável dependente vale 1 na sua 1ª opção. Atenção: é a vaga que ele marcou na inscrição; não medimos se ele foi alocado nem se entrou no município. O funil, à direita, mostra quem sai em cada etapa: dos 5.714 candidatos com 1ª opção, 5.421 entram no modelo.</a:t>
             </a:r>
           </a:p>
           <a:p>
             <a:r>
               <a:rPr lang="pt-BR" dirty="0"/>
               <a:t>DETALHE PARA PERGUNTAS: 1ª opção: listas de classificação dos editais do PMM-E (SGTES/MS), ciclos 1–3, uma linha por candidato e opção. Cada ciclo é um chamamento com quadro de vagas próprio: o ciclo 1 com quadro de 24/07/2025; o ciclo 2 com quadro de 03/02/2026, retificado em 13/02/2026 (o vigente na inscrição, de onde vem o tipo de vaga usado aqui; auditoria 36) e de novo em 19/03/2026; o ciclo 3 com quadro de 16/07/2026. Origem: o município do estabelecimento onde o candidato tinha vínculo médico no CNES antes das inscrições, ligado pelo portão G1 (CPF e nome); não é a residência. Vagas e bolsa: quadros de vagas da 1ª chamada, por célula (estabelecimento × curso), com a faixa da bolsa anunciada (adendo 52c, auditoria 41). IVS 2010 oficial: Plataforma IVS do Ipea; é a variável dos cortes. Distância entre os centroides dos municípios (malha do IBGE); UF e região de saúde (tabela oficial do TabNet). Secundárias, em cinza: porte e capital, controles do modelo. Funil (P1_resumo.json, sem recálculo): 5.714 candidatos com 1ª opção numa vaga do quadro; 5.513 ligados ao CNES; 5.425 com município de origem (vínculo médico na competência anterior à inscrição); 5.421 no modelo, depois de tirar quem tem a origem ou a 1ª opção num município sem região de saúde na tabela oficial. Unidade do modelo: 932.577 pares candidato × vaga, em 56 conjuntos de escolha (curso × ciclo), com 5.125 vagas (estabelecimento × curso). A taxa de ligação é parecida entre alocados e não alocados (G1). Dados pessoais só em memória ou em cache fora do Git.</a:t>
+            </a:r>
+          </a:p>
+          <a:p>
+            <a:r>
+              <a:rPr lang="pt-BR" dirty="0"/>
+              <a:t>Cautela na tela: y = opção marcada, não ida ao município.</a:t>
             </a:r>
           </a:p>
         </p:txBody>
@@ -9403,7 +9409,7 @@
           <a:p>
             <a:r>
               <a:rPr lang="pt-BR" dirty="0"/>
-              <a:t>FALA (0:35): Voltando à pergunta: a bolsa maior aumenta a chance de a vaga ser a 1ª opção, comparando vagas da mesma UF? Sim: 1,47 vez a chance nos três ciclos juntos, e forte só no ciclo 2. Pela teoria da banca 1, o médico aceita a vaga se a bolsa compensa o custo do lugar; os dados sugerem que R$ 5 mil compensam parte desse custo, cerca de 75 km a menos. Isso vale para a escolha de quem se candidatou.</a:t>
+              <a:t>FALA (0:35): Voltando à pergunta: a bolsa maior aumenta a chance de a vaga ser a 1ª opção, comparando vagas da mesma UF? Sim: 1,47 vez a chance nos três ciclos juntos, e forte só no ciclo 2. Pela teoria da banca 1, o médico aceita a vaga se a bolsa compensa o custo do lugar; os dados sugerem que R$ 5 mil compensam parte desse custo, cerca de 75 km a menos. Isso vale para a vaga que quem se candidatou marcou como 1ª opção, não para a entrada no município.</a:t>
             </a:r>
           </a:p>
           <a:p>
@@ -9468,13 +9474,13 @@
           <a:p>
             <a:r>
               <a:rPr lang="pt-BR" dirty="0"/>
-              <a:t>FALA (0:45): Seis limitações e o que cada uma implica. A especificação é pós-resultado: o resultado é exploratório e pede dados novos. Sem fixar a UF, como no pré-registrado, o intervalo contém 1. Só vemos quem se candidatou: nada diz sobre quem não se inscreveu. O contraste é o pacote do corte: vale para o pacote, não para os R$ 5 mil sozinhos. O efeito é forte só no ciclo 2: não dá para generalizar. E a origem é o vínculo no CNES, não a residência. Obrigado.</a:t>
+              <a:t>FALA (0:45): Seis limitações e o que cada uma implica. A especificação é pós-resultado: o resultado é exploratório e pede dados novos. Sem fixar a UF, como no pré-registrado, o intervalo contém 1. Só vemos a inscrição: quem se candidatou e o que marcou, não quem entrou no município. O contraste é o pacote do corte: vale para o pacote, não para os R$ 5 mil sozinhos. O efeito é forte só no ciclo 2: não dá para generalizar. E a origem é o vínculo no CNES, não a residência. Obrigado.</a:t>
             </a:r>
           </a:p>
           <a:p>
             <a:r>
               <a:rPr lang="pt-BR" dirty="0"/>
-              <a:t>DETALHE PARA PERGUNTAS: Implicações, com mais detalhe. Pós-resultado: a hipótese e a especificação com o par de UFs vieram depois dos coeficientes do modelo base; o resultado é exploratório e só vira confirmatório com um protocolo congelado aplicado a dados novos (o universo de inscritos, novos ciclos). Sem fixar a UF: a especificação pré-registrada (P1a) dá 1,25 [0,98; 1,61], IC que contém 1 (p 0,072; família de um teste, Holm = p). Condicional a se candidatar: sem a margem extensiva, nada aqui diz quantos especialistas a mais se inscreveriam com bolsa maior; e o que uma vaga ganha na escolha, outra do mesmo curso perde. Pacote do corte: nos mesmos cortes mudam outras regras federais (auditoria 18); a implicação de política vale para o pacote, não para os R$ 5 mil sozinhos. Só ciclo 2: comparando vagas da mesma UF, ciclo a ciclo (adendo 52g), 1,15 [0,66; 2,01] no ciclo 1 e 1,25 [0,90; 1,73] no ciclo 3, IC que contêm 1; não generalizar para o programa. Origem = vínculo no CNES: quem trabalha longe de casa aparece com a origem do trabalho; ela só define o par de UFs que fica fixo. Perguntas prováveis da banca (doc 66, §8). P1, "Vocês formularam a hipótese depois de ver os resultados?" Sim, e está na tela do slide 1; a especificação com o par de UFs foi congelada antes de rodar (52e; auditoria 48), mas depois de ver o modelo base. P2, "Se o pré-registrado tem IC que contém 1, por que acreditar?" Porque, comparando vagas da mesma UF, o efeito é 1,47 [1,15; 1,89], p de Holm 0,005, e se mantém com o score bootstrap; mas é exploratório. P3, "Isso é a bolsa ou o pacote?" O pacote do corte: nos mesmos cortes mudam outras regras federais (auditoria 18); em 0,300 nenhum outro incentivo individual ao especialista do PMM-E muda (auditoria 35); em 0,400 fica aberta a ajuda de custo do PMMB; nos dois cortes, o serviço do município pode mudar. P4, "E a origem?" Não é a pergunta desta hipótese: a UF de origem é controle. Se insistirem: no modelo base, sem fixar a UF, o teste origem × toda a bolsa (D_UF) dá 1,94 [1,48; 2,40] em log-chance (doc 57p); não é interpretado aqui.</a:t>
+              <a:t>DETALHE PARA PERGUNTAS: Implicações, com mais detalhe. Pós-resultado: a hipótese e a especificação com o par de UFs vieram depois dos coeficientes do modelo base; o resultado é exploratório e só vira confirmatório com um protocolo congelado aplicado a dados novos (o universo de inscritos, novos ciclos). Sem fixar a UF: a especificação pré-registrada (P1a) dá 1,25 [0,98; 1,61], IC que contém 1 (p 0,072; família de um teste, Holm = p). Condicional a se candidatar: sem a margem extensiva, nada aqui diz quantos especialistas a mais se inscreveriam com bolsa maior; e o que uma vaga ganha na escolha, outra do mesmo curso perde. Pacote do corte: nos mesmos cortes mudam outras regras federais (auditoria 18); a implicação de política vale para o pacote, não para os R$ 5 mil sozinhos. Só inscrição: a 1ª opção é a vaga marcada na inscrição; não medimos alocação, posse nem trabalho no município. Só ciclo 2: comparando vagas da mesma UF, ciclo a ciclo (adendo 52g), 1,15 [0,66; 2,01] no ciclo 1 e 1,25 [0,90; 1,73] no ciclo 3, IC que contêm 1; não generalizar para o programa. Origem = vínculo no CNES: quem trabalha longe de casa aparece com a origem do trabalho; ela só define o par de UFs que fica fixo. Perguntas prováveis da banca (doc 66, §8). P1, "Vocês formularam a hipótese depois de ver os resultados?" Sim, e está na tela do slide 1; a especificação com o par de UFs foi congelada antes de rodar (52e; auditoria 48), mas depois de ver o modelo base. P2, "Se o pré-registrado tem IC que contém 1, por que acreditar?" Porque, comparando vagas da mesma UF, o efeito é 1,47 [1,15; 1,89], p de Holm 0,005, e se mantém com o score bootstrap; mas é exploratório. P3, "Isso é a bolsa ou o pacote?" O pacote do corte: nos mesmos cortes mudam outras regras federais (auditoria 18); em 0,300 nenhum outro incentivo individual ao especialista do PMM-E muda (auditoria 35); em 0,400 fica aberta a ajuda de custo do PMMB; nos dois cortes, o serviço do município pode mudar. P4, "E a origem?" Não é a pergunta desta hipótese: a UF de origem é controle. Se insistirem: no modelo base, sem fixar a UF, o teste origem × toda a bolsa (D_UF) dá 1,94 [1,48; 2,40] em log-chance (doc 57p); não é interpretado aqui.</a:t>
             </a:r>
           </a:p>
         </p:txBody>
@@ -16052,6 +16058,64 @@
         </p:nvSpPr>
         <p:spPr>
           <a:xfrm>
+            <a:off x="292608" y="4736592"/>
+            <a:ext cx="11594592" cy="420624"/>
+          </a:xfrm>
+          <a:prstGeom prst="rect">
+            <a:avLst/>
+          </a:prstGeom>
+          <a:noFill/>
+          <a:ln>
+            <a:noFill/>
+          </a:ln>
+        </p:spPr>
+        <p:txBody>
+          <a:bodyPr wrap="square" lIns="164592" tIns="18288" rIns="164592" bIns="18288" rtlCol="0" anchor="ctr">
+            <a:noAutofit/>
+          </a:bodyPr>
+          <a:lstStyle/>
+          <a:p>
+            <a:pPr marL="0" indent="0" algn="l">
+              <a:lnSpc>
+                <a:spcPct val="100000"/>
+              </a:lnSpc>
+              <a:spcBef>
+                <a:spcPts val="0"/>
+              </a:spcBef>
+              <a:spcAft>
+                <a:spcPts val="0"/>
+              </a:spcAft>
+              <a:buNone/>
+            </a:pPr>
+            <a:r>
+              <a:rPr lang="pt-BR" sz="1800" b="1" dirty="0">
+                <a:solidFill>
+                  <a:srgbClr val="114719"/>
+                </a:solidFill>
+                <a:latin typeface="Montserrat"/>
+              </a:rPr>
+              <a:t>Unidade:</a:t>
+            </a:r>
+            <a:r>
+              <a:rPr lang="pt-BR" sz="1800" b="0" dirty="0">
+                <a:solidFill>
+                  <a:srgbClr val="3A3A3A"/>
+                </a:solidFill>
+                <a:latin typeface="Montserrat"/>
+              </a:rPr>
+              <a:t> candidato × vaga do seu curso e ciclo; y = 1 na 1ª opção.</a:t>
+            </a:r>
+          </a:p>
+        </p:txBody>
+      </p:sp>
+      <p:sp>
+        <p:nvSpPr>
+          <p:cNvPr id="102" name="Linha"/>
+          <p:cNvSpPr/>
+          <p:nvPr/>
+        </p:nvSpPr>
+        <p:spPr>
+          <a:xfrm>
             <a:off x="292608" y="5212080"/>
             <a:ext cx="11594592" cy="420624"/>
           </a:xfrm>
@@ -16088,7 +16152,7 @@
                 </a:solidFill>
                 <a:latin typeface="Montserrat"/>
               </a:rPr>
-              <a:t>Unidade:</a:t>
+              <a:t>No modelo:</a:t>
             </a:r>
             <a:r>
               <a:rPr lang="pt-BR" sz="1800" b="0" dirty="0">
@@ -16097,14 +16161,14 @@
                 </a:solidFill>
                 <a:latin typeface="Montserrat"/>
               </a:rPr>
-              <a:t> candidato × vaga do seu curso e ciclo; y = 1 na 1ª opção.</a:t>
+              <a:t> 5.421 candidatos e 932.577 pares candidato × vaga.</a:t>
             </a:r>
           </a:p>
         </p:txBody>
       </p:sp>
       <p:sp>
         <p:nvSpPr>
-          <p:cNvPr id="102" name="Linha"/>
+          <p:cNvPr id="103" name="Cautela"/>
           <p:cNvSpPr/>
           <p:nvPr/>
         </p:nvSpPr>
@@ -16113,10 +16177,14 @@
             <a:off x="292608" y="5687568"/>
             <a:ext cx="11594592" cy="420624"/>
           </a:xfrm>
-          <a:prstGeom prst="rect">
-            <a:avLst/>
+          <a:prstGeom prst="roundRect">
+            <a:avLst>
+              <a:gd name="adj" fmla="val 12000"/>
+            </a:avLst>
           </a:prstGeom>
-          <a:noFill/>
+          <a:solidFill>
+            <a:srgbClr val="E7F1EA"/>
+          </a:solidFill>
           <a:ln>
             <a:noFill/>
           </a:ln>
@@ -16146,23 +16214,14 @@
                 </a:solidFill>
                 <a:latin typeface="Montserrat"/>
               </a:rPr>
-              <a:t>No modelo:</a:t>
-            </a:r>
-            <a:r>
-              <a:rPr lang="pt-BR" sz="1800" b="0" dirty="0">
-                <a:solidFill>
-                  <a:srgbClr val="3A3A3A"/>
-                </a:solidFill>
-                <a:latin typeface="Montserrat"/>
-              </a:rPr>
-              <a:t> 5.421 candidatos e 932.577 pares candidato × vaga.</a:t>
+              <a:t>y = opção marcada, não ida ao município.</a:t>
             </a:r>
           </a:p>
         </p:txBody>
       </p:sp>
       <p:pic>
         <p:nvPicPr>
-          <p:cNvPr id="103" name="Figura" descr="Variáveis e fontes, à esquerda; à direita, o funil da amostra da escolha por ciclo, de quem tem 1ª opção no quadro até quem entra no modelo, com quem sai em cada etapa"/>
+          <p:cNvPr id="104" name="Figura" descr="Variáveis e fontes, à esquerda; à direita, o funil da amostra da escolha por ciclo, de quem tem 1ª opção no quadro até quem entra no modelo, com quem sai em cada etapa"/>
           <p:cNvPicPr>
             <a:picLocks noChangeAspect="1"/>
           </p:cNvPicPr>
@@ -16176,8 +16235,8 @@
         </p:blipFill>
         <p:spPr>
           <a:xfrm>
-            <a:off x="826252" y="804672"/>
-            <a:ext cx="10527304" cy="4279392"/>
+            <a:off x="1411102" y="804672"/>
+            <a:ext cx="9357604" cy="3803904"/>
           </a:xfrm>
           <a:prstGeom prst="rect">
             <a:avLst/>
@@ -16191,7 +16250,7 @@
       </p:pic>
       <p:sp>
         <p:nvSpPr>
-          <p:cNvPr id="104" name="Fontes"/>
+          <p:cNvPr id="105" name="Fontes"/>
           <p:cNvSpPr txBox="1"/>
           <p:nvPr/>
         </p:nvSpPr>
@@ -20714,8 +20773,8 @@
             <a:tbl>
               <a:tblPr firstRow="1" bandRow="1"/>
               <a:tblGrid>
-                <a:gridCol w="5235958"/>
-                <a:gridCol w="6358634"/>
+                <a:gridCol w="5405414"/>
+                <a:gridCol w="6189178"/>
               </a:tblGrid>
               <a:tr h="732826">
                 <a:tc>
@@ -21072,7 +21131,7 @@
                           </a:solidFill>
                           <a:latin typeface="Montserrat"/>
                         </a:rPr>
-                        <a:t>Só candidatos</a:t>
+                        <a:t>Só inscrição</a:t>
                       </a:r>
                     </a:p>
                   </a:txBody>
@@ -21126,7 +21185,7 @@
                           </a:solidFill>
                           <a:latin typeface="Montserrat"/>
                         </a:rPr>
-                        <a:t>sem margem extensiva</a:t>
+                        <a:t>≠ ida ao município</a:t>
                       </a:r>
                     </a:p>
                   </a:txBody>

</xml_diff>

<commit_message>
Deck banca 2: robustez perto do corte com mesma UF e com UF + região (VL-2 e VL-3 do 52e)
Figura do slide 9 ganha a linha 'Perto do corte, UF + região' (VL3_VL2, já
estimado no adendo 52e e auditado na 48); novos códigos VL2_C2_* e VL3P_*;
notas, roteiro e mapa do grupo (doc 10, §6.8). Nada reestimado.

Co-Authored-By: Claude Opus 5.5 <noreply@anthropic.com>
Claude-Session: https://claude.ai/code/session_011jPV4G6BtUxSX71P3Fzkr7
</commit_message>
<xml_diff>
--- a/output/apresentacao_banca2/deck_banca2_curto.pptx
+++ b/output/apresentacao_banca2/deck_banca2_curto.pptx
@@ -9344,13 +9344,13 @@
           <a:p>
             <a:r>
               <a:rPr lang="pt-BR" dirty="0"/>
-              <a:t>FALA (0:40): A robustez fica sempre dentro da mesma UF. À esquerda, o peso da bolsa se mantém com a distância em log e com a região de saúde de origem no lugar da UF de origem. Com poucos grupos, o p do score bootstrap continua 0,011. Só com vagas perto do corte, o intervalo contém 1: inconclusivo. À direita, ciclo a ciclo: o efeito é forte só no ciclo 2; nos ciclos 1 e 3, o intervalo contém 1. Por que o ciclo 2? Não sabemos.</a:t>
+              <a:t>FALA (0:40): A robustez fica sempre dentro da mesma UF. À esquerda, o peso da bolsa se mantém com a distância em log e com a região de saúde de origem no lugar da UF de origem. Com poucos grupos, o p do score bootstrap continua 0,011. Só com vagas perto do corte, comparando na mesma UF ou na mesma UF e região, o intervalo contém 1: inconclusivo. À direita, ciclo a ciclo: o efeito é forte só no ciclo 2; nos ciclos 1 e 3, o intervalo contém 1. Por que o ciclo 2? Não sabemos.</a:t>
             </a:r>
           </a:p>
           <a:p>
             <a:r>
               <a:rPr lang="pt-BR" dirty="0"/>
-              <a:t>DETALHE PARA PERGUNTAS: Todas as variantes comparam vagas da mesma UF. Ciclos 1–3 (adendo 52e; doc 57x; auditoria 48): VL-1, 1,47 [1,15; 1,89]; com a distância em log, 1,45 [1,15; 1,83] (ciclo 2: 1,75 [1,23; 2,49]); com o efeito fixo de região de saúde de origem × UF da vaga (VL-3), 1,49 [1,15; 1,92] (ciclo 2: 1,91 [1,33; 2,74]); só com vagas a até 0,050 de um corte (VL-2), 1,28 [0,95; 1,72], p de Holm 0,103: inconclusivo, a comparação local tem pouca informação. Inferência com poucos clusters (conjuntos de escolha): p do score bootstrap de Rademacher 0,011 nos ciclos 1–3 e 0,004 no ciclo 2, sem ajuste (doc 57x). Por ciclo, com o par de UFs fixado (adendo 52g; doc 57z; pós-resultado; auditoria pendente): ciclo 1, 1,15 [0,66; 2,01], com 16 conjuntos de escolha; ciclo 2, 1,90 [1,30; 2,78]; ciclo 3, 1,25 [0,90; 1,73], com 23 conjuntos. A leitura fixada no adendo antes de rodar: forte só no ciclo 2, como na especificação base. Os km dos ciclos 1 e 3 têm IC que contém zero e não são usados. Por que o ciclo 2, não sabemos (leituras candidatas, sem teste: informação sobre a grade, vagas por curso, parte de vagas imediatas; doc 57a). Tudo pós-resultado e condicional a se candidatar; pacote do corte.</a:t>
+              <a:t>DETALHE PARA PERGUNTAS: Todas as variantes comparam vagas da mesma UF. Ciclos 1–3 (adendo 52e; doc 57x; auditoria 48): VL-1, 1,47 [1,15; 1,89]; com a distância em log, 1,45 [1,15; 1,83] (ciclo 2: 1,75 [1,23; 2,49]); com o efeito fixo de região de saúde de origem × UF da vaga (VL-3), 1,49 [1,15; 1,92] (ciclo 2: 1,91 [1,33; 2,74]); só com vagas a até 0,050 de um corte (VL-2), 1,28 [0,95; 1,72], p de Holm 0,103: inconclusivo, a comparação local tem pouca informação. Perto do corte com a região de saúde de origem × UF da vaga (VL-3 sobre o VL-2): 1,28 [0,95; 1,71], também inconclusivo. No ciclo 2, perto do corte: 1,47 [1,01; 2,14] com o par de UFs e 1,49 [1,04; 2,13] com a região, IC que exclui 1. Inferência com poucos clusters (conjuntos de escolha): p do score bootstrap de Rademacher 0,011 nos ciclos 1–3 e 0,004 no ciclo 2, sem ajuste (doc 57x). Por ciclo, com o par de UFs fixado (adendo 52g; doc 57z; pós-resultado; auditoria pendente): ciclo 1, 1,15 [0,66; 2,01], com 16 conjuntos de escolha; ciclo 2, 1,90 [1,30; 2,78]; ciclo 3, 1,25 [0,90; 1,73], com 23 conjuntos. A leitura fixada no adendo antes de rodar: forte só no ciclo 2, como na especificação base. Os km dos ciclos 1 e 3 têm IC que contém zero e não são usados. Por que o ciclo 2, não sabemos (leituras candidatas, sem teste: informação sobre a grade, vagas por curso, parte de vagas imediatas; doc 57a). Tudo pós-resultado e condicional a se candidatar; pacote do corte.</a:t>
             </a:r>
           </a:p>
         </p:txBody>
@@ -19933,8 +19933,8 @@
         </p:blipFill>
         <p:spPr>
           <a:xfrm>
-            <a:off x="292608" y="821324"/>
-            <a:ext cx="11594592" cy="3770599"/>
+            <a:off x="891235" y="804672"/>
+            <a:ext cx="10397338" cy="3803904"/>
           </a:xfrm>
           <a:prstGeom prst="rect">
             <a:avLst/>

</xml_diff>

<commit_message>
Deck banca 2: efeito por corte (adendo 52h) na robustez do slide 9
Figura ganha 'Degrau 0,300 (10 → 15 mil)' 1,41 e 'Degrau 0,400 (15 → 20 mil)' 1,52,
lidos de VK_estimativas.csv (novos códigos VK1_*, VK2_*, VK1_D_*); linha 'Mantém'
cita 'por degrau'; fala, notas e mapa do grupo (doc 10, §6.9). Auditoria pendente.

Co-Authored-By: Claude Opus 5.5 <noreply@anthropic.com>
Claude-Session: https://claude.ai/code/session_011jPV4G6BtUxSX71P3Fzkr7
</commit_message>
<xml_diff>
--- a/output/apresentacao_banca2/deck_banca2_curto.pptx
+++ b/output/apresentacao_banca2/deck_banca2_curto.pptx
@@ -9344,13 +9344,13 @@
           <a:p>
             <a:r>
               <a:rPr lang="pt-BR" dirty="0"/>
-              <a:t>FALA (0:40): A robustez fica sempre dentro da mesma UF. À esquerda, o peso da bolsa se mantém com a distância em log e com a região de saúde de origem no lugar da UF de origem. Com poucos grupos, o p do score bootstrap continua 0,011. Só com vagas perto do corte, comparando na mesma UF ou na mesma UF e região, o intervalo contém 1: inconclusivo. À direita, ciclo a ciclo: o efeito é forte só no ciclo 2; nos ciclos 1 e 3, o intervalo contém 1. Por que o ciclo 2? Não sabemos.</a:t>
+              <a:t>FALA (0:40): A robustez fica sempre dentro da mesma UF. À esquerda, o peso da bolsa se mantém com a distância em log e com a região de saúde de origem no lugar da UF de origem. Com poucos grupos, o p do score bootstrap continua 0,011. Separando os dois degraus, 0,300 e 0,400, o efeito aparece nos dois e não difere entre eles. Só com vagas perto do corte, comparando na mesma UF ou na mesma UF e região, o intervalo contém 1: inconclusivo. À direita, ciclo a ciclo: o efeito é forte só no ciclo 2; nos ciclos 1 e 3, o intervalo contém 1. Por que o ciclo 2? Não sabemos.</a:t>
             </a:r>
           </a:p>
           <a:p>
             <a:r>
               <a:rPr lang="pt-BR" dirty="0"/>
-              <a:t>DETALHE PARA PERGUNTAS: Todas as variantes comparam vagas da mesma UF. Ciclos 1–3 (adendo 52e; doc 57x; auditoria 48): VL-1, 1,47 [1,15; 1,89]; com a distância em log, 1,45 [1,15; 1,83] (ciclo 2: 1,75 [1,23; 2,49]); com o efeito fixo de região de saúde de origem × UF da vaga (VL-3), 1,49 [1,15; 1,92] (ciclo 2: 1,91 [1,33; 2,74]); só com vagas a até 0,050 de um corte (VL-2), 1,28 [0,95; 1,72], p de Holm 0,103: inconclusivo, a comparação local tem pouca informação. Perto do corte com a região de saúde de origem × UF da vaga (VL-3 sobre o VL-2): 1,28 [0,95; 1,71], também inconclusivo. No ciclo 2, perto do corte: 1,47 [1,01; 2,14] com o par de UFs e 1,49 [1,04; 2,13] com a região, IC que exclui 1. Inferência com poucos clusters (conjuntos de escolha): p do score bootstrap de Rademacher 0,011 nos ciclos 1–3 e 0,004 no ciclo 2, sem ajuste (doc 57x). Por ciclo, com o par de UFs fixado (adendo 52g; doc 57z; pós-resultado; auditoria pendente): ciclo 1, 1,15 [0,66; 2,01], com 16 conjuntos de escolha; ciclo 2, 1,90 [1,30; 2,78]; ciclo 3, 1,25 [0,90; 1,73], com 23 conjuntos. A leitura fixada no adendo antes de rodar: forte só no ciclo 2, como na especificação base. Os km dos ciclos 1 e 3 têm IC que contém zero e não são usados. Por que o ciclo 2, não sabemos (leituras candidatas, sem teste: informação sobre a grade, vagas por curso, parte de vagas imediatas; doc 57a). Tudo pós-resultado e condicional a se candidatar; pacote do corte.</a:t>
+              <a:t>DETALHE PARA PERGUNTAS: Todas as variantes comparam vagas da mesma UF. Ciclos 1–3 (adendo 52e; doc 57x; auditoria 48): VL-1, 1,47 [1,15; 1,89]; com a distância em log, 1,45 [1,15; 1,83] (ciclo 2: 1,75 [1,23; 2,49]); com o efeito fixo de região de saúde de origem × UF da vaga (VL-3), 1,49 [1,15; 1,92] (ciclo 2: 1,91 [1,33; 2,74]); só com vagas a até 0,050 de um corte (VL-2), 1,28 [0,95; 1,72], p de Holm 0,103: inconclusivo, a comparação local tem pouca informação. Perto do corte com a região de saúde de origem × UF da vaga (VL-3 sobre o VL-2): 1,28 [0,95; 1,71], também inconclusivo. No ciclo 2, perto do corte: 1,47 [1,01; 2,14] com o par de UFs e 1,49 [1,04; 2,13] com a região, IC que exclui 1. Por degrau, com o par de UFs fixado (adendo 52h; doc 57za; pós-resultado; auditoria pendente): 0,300, 1,41 [1,03; 1,93]; 0,400, 1,52 [1,16; 1,99]; razão entre os dois 0,93 [0,69; 1,26], p 0,633, sem diferença detectada (no ciclo 2: 1,99 e 1,84). No degrau 0,300 dos ciclos 1–3, o score bootstrap não confirma ao nível de 5%; no 0,400, confirma. Inferência com poucos clusters (conjuntos de escolha): p do score bootstrap de Rademacher 0,011 nos ciclos 1–3 e 0,004 no ciclo 2, sem ajuste (doc 57x). Por ciclo, com o par de UFs fixado (adendo 52g; doc 57z; pós-resultado; auditoria pendente): ciclo 1, 1,15 [0,66; 2,01], com 16 conjuntos de escolha; ciclo 2, 1,90 [1,30; 2,78]; ciclo 3, 1,25 [0,90; 1,73], com 23 conjuntos. A leitura fixada no adendo antes de rodar: forte só no ciclo 2, como na especificação base. Os km dos ciclos 1 e 3 têm IC que contém zero e não são usados. Por que o ciclo 2, não sabemos (leituras candidatas, sem teste: informação sobre a grade, vagas por curso, parte de vagas imediatas; doc 57a). Tudo pós-resultado e condicional a se candidatar; pacote do corte.</a:t>
             </a:r>
           </a:p>
         </p:txBody>
@@ -19796,7 +19796,7 @@
                 </a:solidFill>
                 <a:latin typeface="Montserrat"/>
               </a:rPr>
-              <a:t> log da distância; região × UF; score bootstrap (p 0,011).</a:t>
+              <a:t> log da distância; região × UF; por degrau; score bootstrap.</a:t>
             </a:r>
           </a:p>
         </p:txBody>
@@ -19933,8 +19933,8 @@
         </p:blipFill>
         <p:spPr>
           <a:xfrm>
-            <a:off x="891235" y="804672"/>
-            <a:ext cx="10397338" cy="3803904"/>
+            <a:off x="1836448" y="804672"/>
+            <a:ext cx="8506913" cy="3803904"/>
           </a:xfrm>
           <a:prstGeom prst="rect">
             <a:avLst/>
@@ -19999,7 +19999,7 @@
                 </a:solidFill>
                 <a:latin typeface="Montserrat"/>
               </a:rPr>
-              <a:t>output/rdd_bolsa/VL_estimativas.csv (adendo 52e; doc 57x; auditoria 48); output/rdd_bolsa/VG_estimativas.csv (adendo 52g; doc 57z; auditoria pendente); output/apresentacao_banca2/curto_robustez_escolha.png.</a:t>
+              <a:t>output/rdd_bolsa/VL_estimativas.csv (adendo 52e; doc 57x; auditoria 48); output/rdd_bolsa/VG_estimativas.csv (adendo 52g; doc 57z) e VK_estimativas.csv (adendo 52h; doc 57za), auditoria pendente; output/apresentacao_banca2/curto_robustez_escolha.png.</a:t>
             </a:r>
           </a:p>
         </p:txBody>

</xml_diff>